<commit_message>
docs: shrinkage becomes the headline result; deck to 21 slides
New slide "The biggest gain is where the data is scarcest" with fig9, showing
both the per-budget gain and the monotonic lambda schedule.

Abstract rewritten - 145 words, still under the 150 limit. It previously said
"the gain is small but consistent", which is no longer the honest summary: at
five shots the gain is +0.0515 with 40 of 50 paired episodes won. The abstract
now leads with prototype shrinkage as the contribution rather than with the
importance-weighted metric.

Conclusion slide updated with the headline number.

fig9_shrinkage.png: two panels - gain per budget, and the optimal lambda
falling monotonically from 0.5 at five shots to 0.1 at two hundred. The
schedule was chosen on separate selection episodes and the results shown come
from a third, untouched set.

Deck validated: 21 slides, 8 figures, zero content overflowing the canvas.

Co-Authored-By: Claude Opus 5 <noreply@anthropic.com>
</commit_message>
<xml_diff>
--- a/presentation/StatsGeeks_BuildingAge.pptx
+++ b/presentation/StatsGeeks_BuildingAge.pptx
@@ -25,6 +25,7 @@
     <p:sldId id="273" r:id="rId24"/>
     <p:sldId id="274" r:id="rId25"/>
     <p:sldId id="275" r:id="rId26"/>
+    <p:sldId id="276" r:id="rId27"/>
   </p:sldIdLst>
   <p:sldSz cx="12191695" cy="6858000" type="screen4x3"/>
   <p:notesSz cx="6858000" cy="9144000"/>
@@ -3236,8 +3237,8 @@
                 </a:solidFill>
               </a:rPr>
               <a:t>Building age drives urban retrofit and energy policy, but records are incomplete. We classify the construction era of buildings within 30-metre Landsat pixels into four classes, training on Madrid and adapting to Amsterdam with as few as five labelled examples per class.
-The organiser's starter pipeline appears to perform transfer learning but does not: its Madrid-trained Random Forest is discarded, and Amsterdam prototypes are computed from Amsterdam data alone. We reproduced that baseline exactly, then built a method that genuinely reuses Madrid-learned state - a frozen, importance-weighted distance metric - and demonstrated its benefit against a target-only control on matched, nested episodes.
-The gain is small but consistent across every budget. Our main finding is that the ranking of source representations depends on the label budget: within-class whitening hurts at five shots and helps at two hundred. We report two failed approaches and five stated limitations.</a:t>
+The organiser's starter pipeline appears to perform transfer learning but does not: its Madrid-trained Random Forest is discarded, and Amsterdam prototypes are computed from Amsterdam data alone. We reproduced that baseline exactly, then built a method that genuinely reuses Madrid-learned state.
+Our contribution is prototype shrinkage. An Amsterdam class mean estimated from five pixels is nearly unbiased but very noisy, so we shrink it toward Madrid's class geometry, with the weight falling as target data grows. Five-shot macro F1 rises by 0.0515 over target-only prototypes, winning 40 of 50 paired episodes. The optimal shrinkage declines monotonically with budget, exactly as shrinkage theory predicts.</a:t>
             </a:r>
           </a:p>
         </p:txBody>
@@ -3270,7 +3271,7 @@
                   <a:srgbClr val="55606B"/>
                 </a:solidFill>
               </a:rPr>
-              <a:t>Abstract - 144 words</a:t>
+              <a:t>Abstract</a:t>
             </a:r>
           </a:p>
         </p:txBody>
@@ -3321,7 +3322,7 @@
                   <a:srgbClr val="0E141B"/>
                 </a:solidFill>
               </a:rPr>
-              <a:t>And it replicates</a:t>
+              <a:t>The biggest gain is where the data is scarcest</a:t>
             </a:r>
           </a:p>
         </p:txBody>
@@ -3354,7 +3355,7 @@
                   <a:srgbClr val="55606B"/>
                 </a:solidFill>
               </a:rPr>
-              <a:t>On episodes that did not exist when the method was chosen</a:t>
+              <a:t>Prototype shrinkage toward Madrid's class geometry</a:t>
             </a:r>
           </a:p>
         </p:txBody>
@@ -3395,7 +3396,7 @@
       </p:sp>
       <p:pic>
         <p:nvPicPr>
-          <p:cNvPr id="5" name="Picture 4" descr="fig8_replication.png"/>
+          <p:cNvPr id="5" name="Picture 4" descr="fig9_shrinkage.png"/>
           <p:cNvPicPr>
             <a:picLocks noChangeAspect="1"/>
           </p:cNvPicPr>
@@ -3409,8 +3410,8 @@
         </p:blipFill>
         <p:spPr>
           <a:xfrm>
-            <a:off x="640080" y="1783080"/>
-            <a:ext cx="6696241" cy="4206240"/>
+            <a:off x="411480" y="1828800"/>
+            <a:ext cx="7447788" cy="3200400"/>
           </a:xfrm>
           <a:prstGeom prst="rect">
             <a:avLst/>
@@ -3425,27 +3426,27 @@
         </p:nvSpPr>
         <p:spPr>
           <a:xfrm>
-            <a:off x="6126480" y="1920240"/>
-            <a:ext cx="5486400" cy="411480"/>
-          </a:xfrm>
-          <a:prstGeom prst="rect">
-            <a:avLst/>
-          </a:prstGeom>
-          <a:noFill/>
-        </p:spPr>
-        <p:txBody>
-          <a:bodyPr wrap="square">
-            <a:spAutoFit/>
-          </a:bodyPr>
-          <a:lstStyle/>
-          <a:p>
-            <a:r>
-              <a:rPr sz="1500" b="1">
+            <a:off x="4206240" y="1783080"/>
+            <a:ext cx="7680960" cy="411480"/>
+          </a:xfrm>
+          <a:prstGeom prst="rect">
+            <a:avLst/>
+          </a:prstGeom>
+          <a:noFill/>
+        </p:spPr>
+        <p:txBody>
+          <a:bodyPr wrap="square">
+            <a:spAutoFit/>
+          </a:bodyPr>
+          <a:lstStyle/>
+          <a:p>
+            <a:r>
+              <a:rPr sz="1300" b="1">
                 <a:solidFill>
                   <a:srgbClr val="0E141B"/>
                 </a:solidFill>
               </a:rPr>
-              <a:t>The method was fixed on one episode set.</a:t>
+              <a:t>At 5 shots, an Amsterdam class mean comes from 5 points in 60 dimensions.</a:t>
             </a:r>
           </a:p>
         </p:txBody>
@@ -3458,93 +3459,93 @@
         </p:nvSpPr>
         <p:spPr>
           <a:xfrm>
-            <a:off x="6126480" y="2304288"/>
-            <a:ext cx="5486400" cy="411480"/>
-          </a:xfrm>
-          <a:prstGeom prst="rect">
-            <a:avLst/>
-          </a:prstGeom>
-          <a:noFill/>
-        </p:spPr>
-        <p:txBody>
-          <a:bodyPr wrap="square">
-            <a:spAutoFit/>
-          </a:bodyPr>
-          <a:lstStyle/>
-          <a:p>
-            <a:r>
-              <a:rPr sz="1500" b="1">
+            <a:off x="4206240" y="2103120"/>
+            <a:ext cx="7680960" cy="411480"/>
+          </a:xfrm>
+          <a:prstGeom prst="rect">
+            <a:avLst/>
+          </a:prstGeom>
+          <a:noFill/>
+        </p:spPr>
+        <p:txBody>
+          <a:bodyPr wrap="square">
+            <a:spAutoFit/>
+          </a:bodyPr>
+          <a:lstStyle/>
+          <a:p>
+            <a:r>
+              <a:rPr sz="1300" b="0">
+                <a:solidFill>
+                  <a:srgbClr val="55606B"/>
+                </a:solidFill>
+              </a:rPr>
+              <a:t>Nearly unbiased, but very noisy. Madrid's prototype comes from 76,263 pixels:</a:t>
+            </a:r>
+          </a:p>
+        </p:txBody>
+      </p:sp>
+      <p:sp>
+        <p:nvSpPr>
+          <p:cNvPr id="8" name="TextBox 7"/>
+          <p:cNvSpPr txBox="1"/>
+          <p:nvPr/>
+        </p:nvSpPr>
+        <p:spPr>
+          <a:xfrm>
+            <a:off x="4206240" y="2423160"/>
+            <a:ext cx="7680960" cy="411480"/>
+          </a:xfrm>
+          <a:prstGeom prst="rect">
+            <a:avLst/>
+          </a:prstGeom>
+          <a:noFill/>
+        </p:spPr>
+        <p:txBody>
+          <a:bodyPr wrap="square">
+            <a:spAutoFit/>
+          </a:bodyPr>
+          <a:lstStyle/>
+          <a:p>
+            <a:r>
+              <a:rPr sz="1300" b="0">
+                <a:solidFill>
+                  <a:srgbClr val="55606B"/>
+                </a:solidFill>
+              </a:rPr>
+              <a:t>biased, because it is a different city, but stable.</a:t>
+            </a:r>
+          </a:p>
+        </p:txBody>
+      </p:sp>
+      <p:sp>
+        <p:nvSpPr>
+          <p:cNvPr id="9" name="TextBox 8"/>
+          <p:cNvSpPr txBox="1"/>
+          <p:nvPr/>
+        </p:nvSpPr>
+        <p:spPr>
+          <a:xfrm>
+            <a:off x="4206240" y="3063239"/>
+            <a:ext cx="7680960" cy="411480"/>
+          </a:xfrm>
+          <a:prstGeom prst="rect">
+            <a:avLst/>
+          </a:prstGeom>
+          <a:noFill/>
+        </p:spPr>
+        <p:txBody>
+          <a:bodyPr wrap="square">
+            <a:spAutoFit/>
+          </a:bodyPr>
+          <a:lstStyle/>
+          <a:p>
+            <a:r>
+              <a:rPr sz="1300" b="1">
                 <a:solidFill>
                   <a:srgbClr val="0E141B"/>
                 </a:solidFill>
               </a:rPr>
-              <a:t>Then tested on a brand new one, seed 2026.</a:t>
-            </a:r>
-          </a:p>
-        </p:txBody>
-      </p:sp>
-      <p:sp>
-        <p:nvSpPr>
-          <p:cNvPr id="8" name="TextBox 7"/>
-          <p:cNvSpPr txBox="1"/>
-          <p:nvPr/>
-        </p:nvSpPr>
-        <p:spPr>
-          <a:xfrm>
-            <a:off x="6126480" y="3072384"/>
-            <a:ext cx="5486400" cy="411480"/>
-          </a:xfrm>
-          <a:prstGeom prst="rect">
-            <a:avLst/>
-          </a:prstGeom>
-          <a:noFill/>
-        </p:spPr>
-        <p:txBody>
-          <a:bodyPr wrap="square">
-            <a:spAutoFit/>
-          </a:bodyPr>
-          <a:lstStyle/>
-          <a:p>
-            <a:r>
-              <a:rPr sz="1500" b="0">
-                <a:solidFill>
-                  <a:srgbClr val="55606B"/>
-                </a:solidFill>
-              </a:rPr>
-              <a:t>19 of 25 paired episodes won.</a:t>
-            </a:r>
-          </a:p>
-        </p:txBody>
-      </p:sp>
-      <p:sp>
-        <p:nvSpPr>
-          <p:cNvPr id="9" name="TextBox 8"/>
-          <p:cNvSpPr txBox="1"/>
-          <p:nvPr/>
-        </p:nvSpPr>
-        <p:spPr>
-          <a:xfrm>
-            <a:off x="6126480" y="3456432"/>
-            <a:ext cx="5486400" cy="411480"/>
-          </a:xfrm>
-          <a:prstGeom prst="rect">
-            <a:avLst/>
-          </a:prstGeom>
-          <a:noFill/>
-        </p:spPr>
-        <p:txBody>
-          <a:bodyPr wrap="square">
-            <a:spAutoFit/>
-          </a:bodyPr>
-          <a:lstStyle/>
-          <a:p>
-            <a:r>
-              <a:rPr sz="1500" b="0">
-                <a:solidFill>
-                  <a:srgbClr val="55606B"/>
-                </a:solidFill>
-              </a:rPr>
-              <a:t>Positive at every budget, in both runs.</a:t>
+              <a:t>So shrink the noisy estimate toward the stable one:</a:t>
             </a:r>
           </a:p>
         </p:txBody>
@@ -3557,60 +3558,60 @@
         </p:nvSpPr>
         <p:spPr>
           <a:xfrm>
-            <a:off x="6126480" y="4224528"/>
-            <a:ext cx="5486400" cy="411480"/>
-          </a:xfrm>
-          <a:prstGeom prst="rect">
-            <a:avLst/>
-          </a:prstGeom>
-          <a:noFill/>
-        </p:spPr>
-        <p:txBody>
-          <a:bodyPr wrap="square">
-            <a:spAutoFit/>
-          </a:bodyPr>
-          <a:lstStyle/>
-          <a:p>
-            <a:r>
-              <a:rPr sz="1500" b="1">
+            <a:off x="4206240" y="3383280"/>
+            <a:ext cx="7680960" cy="411480"/>
+          </a:xfrm>
+          <a:prstGeom prst="rect">
+            <a:avLst/>
+          </a:prstGeom>
+          <a:noFill/>
+        </p:spPr>
+        <p:txBody>
+          <a:bodyPr wrap="square">
+            <a:spAutoFit/>
+          </a:bodyPr>
+          <a:lstStyle/>
+          <a:p>
+            <a:r>
+              <a:rPr sz="1300" b="0">
+                <a:solidFill>
+                  <a:srgbClr val="55606B"/>
+                </a:solidFill>
+              </a:rPr>
+              <a:t>        p = mu_A  +  lambda (Madrid class offset)  +  (1-lambda)(support mean - mu_A)</a:t>
+            </a:r>
+          </a:p>
+        </p:txBody>
+      </p:sp>
+      <p:sp>
+        <p:nvSpPr>
+          <p:cNvPr id="11" name="TextBox 10"/>
+          <p:cNvSpPr txBox="1"/>
+          <p:nvPr/>
+        </p:nvSpPr>
+        <p:spPr>
+          <a:xfrm>
+            <a:off x="4206240" y="4023359"/>
+            <a:ext cx="7680960" cy="411480"/>
+          </a:xfrm>
+          <a:prstGeom prst="rect">
+            <a:avLst/>
+          </a:prstGeom>
+          <a:noFill/>
+        </p:spPr>
+        <p:txBody>
+          <a:bodyPr wrap="square">
+            <a:spAutoFit/>
+          </a:bodyPr>
+          <a:lstStyle/>
+          <a:p>
+            <a:r>
+              <a:rPr sz="1300" b="1">
                 <a:solidFill>
                   <a:srgbClr val="0E141B"/>
                 </a:solidFill>
               </a:rPr>
-              <a:t>The 5-shot gain is the largest: +0.0178 -</a:t>
-            </a:r>
-          </a:p>
-        </p:txBody>
-      </p:sp>
-      <p:sp>
-        <p:nvSpPr>
-          <p:cNvPr id="11" name="TextBox 10"/>
-          <p:cNvSpPr txBox="1"/>
-          <p:nvPr/>
-        </p:nvSpPr>
-        <p:spPr>
-          <a:xfrm>
-            <a:off x="6126480" y="4608576"/>
-            <a:ext cx="5486400" cy="411480"/>
-          </a:xfrm>
-          <a:prstGeom prst="rect">
-            <a:avLst/>
-          </a:prstGeom>
-          <a:noFill/>
-        </p:spPr>
-        <p:txBody>
-          <a:bodyPr wrap="square">
-            <a:spAutoFit/>
-          </a:bodyPr>
-          <a:lstStyle/>
-          <a:p>
-            <a:r>
-              <a:rPr sz="1500" b="0">
-                <a:solidFill>
-                  <a:srgbClr val="55606B"/>
-                </a:solidFill>
-              </a:rPr>
-              <a:t>the regime the challenge actually cares about.</a:t>
+              <a:t>+0.0515 macro F1 at 5 shots. 40 of 50 paired episodes won.</a:t>
             </a:r>
           </a:p>
         </p:txBody>
@@ -3623,27 +3624,27 @@
         </p:nvSpPr>
         <p:spPr>
           <a:xfrm>
-            <a:off x="6126480" y="5376672"/>
-            <a:ext cx="5486400" cy="411480"/>
-          </a:xfrm>
-          <a:prstGeom prst="rect">
-            <a:avLst/>
-          </a:prstGeom>
-          <a:noFill/>
-        </p:spPr>
-        <p:txBody>
-          <a:bodyPr wrap="square">
-            <a:spAutoFit/>
-          </a:bodyPr>
-          <a:lstStyle/>
-          <a:p>
-            <a:r>
-              <a:rPr sz="1500" b="1">
+            <a:off x="4206240" y="4663440"/>
+            <a:ext cx="7680960" cy="411480"/>
+          </a:xfrm>
+          <a:prstGeom prst="rect">
+            <a:avLst/>
+          </a:prstGeom>
+          <a:noFill/>
+        </p:spPr>
+        <p:txBody>
+          <a:bodyPr wrap="square">
+            <a:spAutoFit/>
+          </a:bodyPr>
+          <a:lstStyle/>
+          <a:p>
+            <a:r>
+              <a:rPr sz="1300" b="1">
                 <a:solidFill>
                   <a:srgbClr val="0E141B"/>
                 </a:solidFill>
               </a:rPr>
-              <a:t>This is external validation, not a re-audit</a:t>
+              <a:t>And the optimal lambda falls monotonically as target data grows -</a:t>
             </a:r>
           </a:p>
         </p:txBody>
@@ -3656,27 +3657,93 @@
         </p:nvSpPr>
         <p:spPr>
           <a:xfrm>
-            <a:off x="6126480" y="5760720"/>
-            <a:ext cx="5486400" cy="411480"/>
-          </a:xfrm>
-          <a:prstGeom prst="rect">
-            <a:avLst/>
-          </a:prstGeom>
-          <a:noFill/>
-        </p:spPr>
-        <p:txBody>
-          <a:bodyPr wrap="square">
-            <a:spAutoFit/>
-          </a:bodyPr>
-          <a:lstStyle/>
-          <a:p>
-            <a:r>
-              <a:rPr sz="1500" b="1">
-                <a:solidFill>
-                  <a:srgbClr val="0E141B"/>
-                </a:solidFill>
-              </a:rPr>
-              <a:t>of the set we selected on.</a:t>
+            <a:off x="4206240" y="4983480"/>
+            <a:ext cx="7680960" cy="411480"/>
+          </a:xfrm>
+          <a:prstGeom prst="rect">
+            <a:avLst/>
+          </a:prstGeom>
+          <a:noFill/>
+        </p:spPr>
+        <p:txBody>
+          <a:bodyPr wrap="square">
+            <a:spAutoFit/>
+          </a:bodyPr>
+          <a:lstStyle/>
+          <a:p>
+            <a:r>
+              <a:rPr sz="1300" b="0">
+                <a:solidFill>
+                  <a:srgbClr val="55606B"/>
+                </a:solidFill>
+              </a:rPr>
+              <a:t>0.5 at five shots, 0.1 at two hundred. We did not impose that; it is what</a:t>
+            </a:r>
+          </a:p>
+        </p:txBody>
+      </p:sp>
+      <p:sp>
+        <p:nvSpPr>
+          <p:cNvPr id="14" name="TextBox 13"/>
+          <p:cNvSpPr txBox="1"/>
+          <p:nvPr/>
+        </p:nvSpPr>
+        <p:spPr>
+          <a:xfrm>
+            <a:off x="4206240" y="5303520"/>
+            <a:ext cx="7680960" cy="411480"/>
+          </a:xfrm>
+          <a:prstGeom prst="rect">
+            <a:avLst/>
+          </a:prstGeom>
+          <a:noFill/>
+        </p:spPr>
+        <p:txBody>
+          <a:bodyPr wrap="square">
+            <a:spAutoFit/>
+          </a:bodyPr>
+          <a:lstStyle/>
+          <a:p>
+            <a:r>
+              <a:rPr sz="1300" b="0">
+                <a:solidFill>
+                  <a:srgbClr val="55606B"/>
+                </a:solidFill>
+              </a:rPr>
+              <a:t>shrinkage theory predicts, recovered from the data.</a:t>
+            </a:r>
+          </a:p>
+        </p:txBody>
+      </p:sp>
+      <p:sp>
+        <p:nvSpPr>
+          <p:cNvPr id="15" name="TextBox 14"/>
+          <p:cNvSpPr txBox="1"/>
+          <p:nvPr/>
+        </p:nvSpPr>
+        <p:spPr>
+          <a:xfrm>
+            <a:off x="4206240" y="5943600"/>
+            <a:ext cx="7680960" cy="411480"/>
+          </a:xfrm>
+          <a:prstGeom prst="rect">
+            <a:avLst/>
+          </a:prstGeom>
+          <a:noFill/>
+        </p:spPr>
+        <p:txBody>
+          <a:bodyPr wrap="square">
+            <a:spAutoFit/>
+          </a:bodyPr>
+          <a:lstStyle/>
+          <a:p>
+            <a:r>
+              <a:rPr sz="1300" b="0">
+                <a:solidFill>
+                  <a:srgbClr val="55606B"/>
+                </a:solidFill>
+              </a:rPr>
+              <a:t>mu_A uses the SUPPORT set only. Query features are never touched.</a:t>
             </a:r>
           </a:p>
         </p:txBody>
@@ -3727,7 +3794,7 @@
                   <a:srgbClr val="0E141B"/>
                 </a:solidFill>
               </a:rPr>
-              <a:t>What is worth transferring from Madrid?</a:t>
+              <a:t>And it replicates</a:t>
             </a:r>
           </a:p>
         </p:txBody>
@@ -3760,7 +3827,7 @@
                   <a:srgbClr val="55606B"/>
                 </a:solidFill>
               </a:rPr>
-              <a:t>Nine frozen source representations, identical procedure otherwise</a:t>
+              <a:t>On episodes that did not exist when the method was chosen</a:t>
             </a:r>
           </a:p>
         </p:txBody>
@@ -3794,14 +3861,14 @@
                   <a:srgbClr val="55606B"/>
                 </a:solidFill>
               </a:rPr>
-              <a:t>M3 &gt; M4</a:t>
+              <a:t>M3</a:t>
             </a:r>
           </a:p>
         </p:txBody>
       </p:sp>
       <p:pic>
         <p:nvPicPr>
-          <p:cNvPr id="5" name="Picture 4" descr="fig3_method_ablation.png"/>
+          <p:cNvPr id="5" name="Picture 4" descr="fig8_replication.png"/>
           <p:cNvPicPr>
             <a:picLocks noChangeAspect="1"/>
           </p:cNvPicPr>
@@ -3815,8 +3882,8 @@
         </p:blipFill>
         <p:spPr>
           <a:xfrm>
-            <a:off x="548640" y="1783080"/>
-            <a:ext cx="7529906" cy="4389120"/>
+            <a:off x="640080" y="1783080"/>
+            <a:ext cx="6696241" cy="4206240"/>
           </a:xfrm>
           <a:prstGeom prst="rect">
             <a:avLst/>
@@ -3831,8 +3898,8 @@
         </p:nvSpPr>
         <p:spPr>
           <a:xfrm>
-            <a:off x="6309360" y="1965960"/>
-            <a:ext cx="5394960" cy="411480"/>
+            <a:off x="6126480" y="1920240"/>
+            <a:ext cx="5486400" cy="411480"/>
           </a:xfrm>
           <a:prstGeom prst="rect">
             <a:avLst/>
@@ -3851,7 +3918,7 @@
                   <a:srgbClr val="0E141B"/>
                 </a:solidFill>
               </a:rPr>
-              <a:t>The crude method beat the clever ones.</a:t>
+              <a:t>The method was fixed on one episode set.</a:t>
             </a:r>
           </a:p>
         </p:txBody>
@@ -3864,8 +3931,41 @@
         </p:nvSpPr>
         <p:spPr>
           <a:xfrm>
-            <a:off x="6309360" y="2770632"/>
-            <a:ext cx="5394960" cy="411480"/>
+            <a:off x="6126480" y="2304288"/>
+            <a:ext cx="5486400" cy="411480"/>
+          </a:xfrm>
+          <a:prstGeom prst="rect">
+            <a:avLst/>
+          </a:prstGeom>
+          <a:noFill/>
+        </p:spPr>
+        <p:txBody>
+          <a:bodyPr wrap="square">
+            <a:spAutoFit/>
+          </a:bodyPr>
+          <a:lstStyle/>
+          <a:p>
+            <a:r>
+              <a:rPr sz="1500" b="1">
+                <a:solidFill>
+                  <a:srgbClr val="0E141B"/>
+                </a:solidFill>
+              </a:rPr>
+              <a:t>Then tested on a brand new one, seed 2026.</a:t>
+            </a:r>
+          </a:p>
+        </p:txBody>
+      </p:sp>
+      <p:sp>
+        <p:nvSpPr>
+          <p:cNvPr id="8" name="TextBox 7"/>
+          <p:cNvSpPr txBox="1"/>
+          <p:nvPr/>
+        </p:nvSpPr>
+        <p:spPr>
+          <a:xfrm>
+            <a:off x="6126480" y="3072384"/>
+            <a:ext cx="5486400" cy="411480"/>
           </a:xfrm>
           <a:prstGeom prst="rect">
             <a:avLst/>
@@ -3884,21 +3984,21 @@
                   <a:srgbClr val="55606B"/>
                 </a:solidFill>
               </a:rPr>
-              <a:t>Importance weighting worked.</a:t>
-            </a:r>
-          </a:p>
-        </p:txBody>
-      </p:sp>
-      <p:sp>
-        <p:nvSpPr>
-          <p:cNvPr id="8" name="TextBox 7"/>
-          <p:cNvSpPr txBox="1"/>
-          <p:nvPr/>
-        </p:nvSpPr>
-        <p:spPr>
-          <a:xfrm>
-            <a:off x="6309360" y="3172968"/>
-            <a:ext cx="5394960" cy="411480"/>
+              <a:t>19 of 25 paired episodes won.</a:t>
+            </a:r>
+          </a:p>
+        </p:txBody>
+      </p:sp>
+      <p:sp>
+        <p:nvSpPr>
+          <p:cNvPr id="9" name="TextBox 8"/>
+          <p:cNvSpPr txBox="1"/>
+          <p:nvPr/>
+        </p:nvSpPr>
+        <p:spPr>
+          <a:xfrm>
+            <a:off x="6126480" y="3456432"/>
+            <a:ext cx="5486400" cy="411480"/>
           </a:xfrm>
           <a:prstGeom prst="rect">
             <a:avLst/>
@@ -3917,21 +4017,54 @@
                   <a:srgbClr val="55606B"/>
                 </a:solidFill>
               </a:rPr>
-              <a:t>Rank-3 LDA hurt.</a:t>
-            </a:r>
-          </a:p>
-        </p:txBody>
-      </p:sp>
-      <p:sp>
-        <p:nvSpPr>
-          <p:cNvPr id="9" name="TextBox 8"/>
-          <p:cNvSpPr txBox="1"/>
-          <p:nvPr/>
-        </p:nvSpPr>
-        <p:spPr>
-          <a:xfrm>
-            <a:off x="6309360" y="3575304"/>
-            <a:ext cx="5394960" cy="411480"/>
+              <a:t>Positive at every budget, in both runs.</a:t>
+            </a:r>
+          </a:p>
+        </p:txBody>
+      </p:sp>
+      <p:sp>
+        <p:nvSpPr>
+          <p:cNvPr id="10" name="TextBox 9"/>
+          <p:cNvSpPr txBox="1"/>
+          <p:nvPr/>
+        </p:nvSpPr>
+        <p:spPr>
+          <a:xfrm>
+            <a:off x="6126480" y="4224528"/>
+            <a:ext cx="5486400" cy="411480"/>
+          </a:xfrm>
+          <a:prstGeom prst="rect">
+            <a:avLst/>
+          </a:prstGeom>
+          <a:noFill/>
+        </p:spPr>
+        <p:txBody>
+          <a:bodyPr wrap="square">
+            <a:spAutoFit/>
+          </a:bodyPr>
+          <a:lstStyle/>
+          <a:p>
+            <a:r>
+              <a:rPr sz="1500" b="1">
+                <a:solidFill>
+                  <a:srgbClr val="0E141B"/>
+                </a:solidFill>
+              </a:rPr>
+              <a:t>The 5-shot gain is the largest: +0.0178 -</a:t>
+            </a:r>
+          </a:p>
+        </p:txBody>
+      </p:sp>
+      <p:sp>
+        <p:nvSpPr>
+          <p:cNvPr id="11" name="TextBox 10"/>
+          <p:cNvSpPr txBox="1"/>
+          <p:nvPr/>
+        </p:nvSpPr>
+        <p:spPr>
+          <a:xfrm>
+            <a:off x="6126480" y="4608576"/>
+            <a:ext cx="5486400" cy="411480"/>
           </a:xfrm>
           <a:prstGeom prst="rect">
             <a:avLst/>
@@ -3950,54 +4083,21 @@
                   <a:srgbClr val="55606B"/>
                 </a:solidFill>
               </a:rPr>
-              <a:t>The classifier's own probability space hurt</a:t>
-            </a:r>
-          </a:p>
-        </p:txBody>
-      </p:sp>
-      <p:sp>
-        <p:nvSpPr>
-          <p:cNvPr id="10" name="TextBox 9"/>
-          <p:cNvSpPr txBox="1"/>
-          <p:nvPr/>
-        </p:nvSpPr>
-        <p:spPr>
-          <a:xfrm>
-            <a:off x="6309360" y="3977639"/>
-            <a:ext cx="5394960" cy="411480"/>
-          </a:xfrm>
-          <a:prstGeom prst="rect">
-            <a:avLst/>
-          </a:prstGeom>
-          <a:noFill/>
-        </p:spPr>
-        <p:txBody>
-          <a:bodyPr wrap="square">
-            <a:spAutoFit/>
-          </a:bodyPr>
-          <a:lstStyle/>
-          <a:p>
-            <a:r>
-              <a:rPr sz="1500" b="0">
-                <a:solidFill>
-                  <a:srgbClr val="55606B"/>
-                </a:solidFill>
-              </a:rPr>
-              <a:t>badly - the worst of the nine.</a:t>
-            </a:r>
-          </a:p>
-        </p:txBody>
-      </p:sp>
-      <p:sp>
-        <p:nvSpPr>
-          <p:cNvPr id="11" name="TextBox 10"/>
-          <p:cNvSpPr txBox="1"/>
-          <p:nvPr/>
-        </p:nvSpPr>
-        <p:spPr>
-          <a:xfrm>
-            <a:off x="6309360" y="4782312"/>
-            <a:ext cx="5394960" cy="411480"/>
+              <a:t>the regime the challenge actually cares about.</a:t>
+            </a:r>
+          </a:p>
+        </p:txBody>
+      </p:sp>
+      <p:sp>
+        <p:nvSpPr>
+          <p:cNvPr id="12" name="TextBox 11"/>
+          <p:cNvSpPr txBox="1"/>
+          <p:nvPr/>
+        </p:nvSpPr>
+        <p:spPr>
+          <a:xfrm>
+            <a:off x="6126480" y="5376672"/>
+            <a:ext cx="5486400" cy="411480"/>
           </a:xfrm>
           <a:prstGeom prst="rect">
             <a:avLst/>
@@ -4016,21 +4116,21 @@
                   <a:srgbClr val="0E141B"/>
                 </a:solidFill>
               </a:rPr>
-              <a:t>Both compress 60 dimensions into 3-4 and</a:t>
-            </a:r>
-          </a:p>
-        </p:txBody>
-      </p:sp>
-      <p:sp>
-        <p:nvSpPr>
-          <p:cNvPr id="12" name="TextBox 11"/>
-          <p:cNvSpPr txBox="1"/>
-          <p:nvPr/>
-        </p:nvSpPr>
-        <p:spPr>
-          <a:xfrm>
-            <a:off x="6309360" y="5184648"/>
-            <a:ext cx="5394960" cy="411480"/>
+              <a:t>This is external validation, not a re-audit</a:t>
+            </a:r>
+          </a:p>
+        </p:txBody>
+      </p:sp>
+      <p:sp>
+        <p:nvSpPr>
+          <p:cNvPr id="13" name="TextBox 12"/>
+          <p:cNvSpPr txBox="1"/>
+          <p:nvPr/>
+        </p:nvSpPr>
+        <p:spPr>
+          <a:xfrm>
+            <a:off x="6126480" y="5760720"/>
+            <a:ext cx="5486400" cy="411480"/>
           </a:xfrm>
           <a:prstGeom prst="rect">
             <a:avLst/>
@@ -4049,7 +4149,7 @@
                   <a:srgbClr val="0E141B"/>
                 </a:solidFill>
               </a:rPr>
-              <a:t>discard what Amsterdam needs.</a:t>
+              <a:t>of the set we selected on.</a:t>
             </a:r>
           </a:p>
         </p:txBody>
@@ -4100,7 +4200,7 @@
                   <a:srgbClr val="0E141B"/>
                 </a:solidFill>
               </a:rPr>
-              <a:t>The ranking depends on the label budget</a:t>
+              <a:t>What is worth transferring from Madrid?</a:t>
             </a:r>
           </a:p>
         </p:txBody>
@@ -4133,7 +4233,7 @@
                   <a:srgbClr val="55606B"/>
                 </a:solidFill>
               </a:rPr>
-              <a:t>Same transform, opposite verdict</a:t>
+              <a:t>Nine frozen source representations, identical procedure otherwise</a:t>
             </a:r>
           </a:p>
         </p:txBody>
@@ -4167,14 +4267,14 @@
                   <a:srgbClr val="55606B"/>
                 </a:solidFill>
               </a:rPr>
-              <a:t>M4</a:t>
+              <a:t>M3 &gt; M4</a:t>
             </a:r>
           </a:p>
         </p:txBody>
       </p:sp>
       <p:pic>
         <p:nvPicPr>
-          <p:cNvPr id="5" name="Picture 4" descr="fig4_budget_dependence.png"/>
+          <p:cNvPr id="5" name="Picture 4" descr="fig3_method_ablation.png"/>
           <p:cNvPicPr>
             <a:picLocks noChangeAspect="1"/>
           </p:cNvPicPr>
@@ -4189,7 +4289,7 @@
         <p:spPr>
           <a:xfrm>
             <a:off x="548640" y="1783080"/>
-            <a:ext cx="7982299" cy="4297680"/>
+            <a:ext cx="7529906" cy="4389120"/>
           </a:xfrm>
           <a:prstGeom prst="rect">
             <a:avLst/>
@@ -4204,7 +4304,7 @@
         </p:nvSpPr>
         <p:spPr>
           <a:xfrm>
-            <a:off x="6217920" y="1920240"/>
+            <a:off x="6309360" y="1965960"/>
             <a:ext cx="5394960" cy="411480"/>
           </a:xfrm>
           <a:prstGeom prst="rect">
@@ -4224,7 +4324,7 @@
                   <a:srgbClr val="0E141B"/>
                 </a:solidFill>
               </a:rPr>
-              <a:t>Within-class whitening:</a:t>
+              <a:t>The crude method beat the clever ones.</a:t>
             </a:r>
           </a:p>
         </p:txBody>
@@ -4237,7 +4337,7 @@
         </p:nvSpPr>
         <p:spPr>
           <a:xfrm>
-            <a:off x="6217920" y="2304288"/>
+            <a:off x="6309360" y="2770632"/>
             <a:ext cx="5394960" cy="411480"/>
           </a:xfrm>
           <a:prstGeom prst="rect">
@@ -4257,7 +4357,7 @@
                   <a:srgbClr val="55606B"/>
                 </a:solidFill>
               </a:rPr>
-              <a:t>        -0.0218 at 5 shots</a:t>
+              <a:t>Importance weighting worked.</a:t>
             </a:r>
           </a:p>
         </p:txBody>
@@ -4270,7 +4370,7 @@
         </p:nvSpPr>
         <p:spPr>
           <a:xfrm>
-            <a:off x="6217920" y="2688336"/>
+            <a:off x="6309360" y="3172968"/>
             <a:ext cx="5394960" cy="411480"/>
           </a:xfrm>
           <a:prstGeom prst="rect">
@@ -4290,7 +4390,7 @@
                   <a:srgbClr val="55606B"/>
                 </a:solidFill>
               </a:rPr>
-              <a:t>        +0.0090 at 200 shots</a:t>
+              <a:t>Rank-3 LDA hurt.</a:t>
             </a:r>
           </a:p>
         </p:txBody>
@@ -4303,7 +4403,7 @@
         </p:nvSpPr>
         <p:spPr>
           <a:xfrm>
-            <a:off x="6217920" y="3456432"/>
+            <a:off x="6309360" y="3575304"/>
             <a:ext cx="5394960" cy="411480"/>
           </a:xfrm>
           <a:prstGeom prst="rect">
@@ -4323,7 +4423,7 @@
                   <a:srgbClr val="55606B"/>
                 </a:solidFill>
               </a:rPr>
-              <a:t>Whitening amplifies low-variance directions.</a:t>
+              <a:t>The classifier's own probability space hurt</a:t>
             </a:r>
           </a:p>
         </p:txBody>
@@ -4336,7 +4436,7 @@
         </p:nvSpPr>
         <p:spPr>
           <a:xfrm>
-            <a:off x="6217920" y="3840480"/>
+            <a:off x="6309360" y="3977639"/>
             <a:ext cx="5394960" cy="411480"/>
           </a:xfrm>
           <a:prstGeom prst="rect">
@@ -4356,7 +4456,7 @@
                   <a:srgbClr val="55606B"/>
                 </a:solidFill>
               </a:rPr>
-              <a:t>Destructive when 5 points must estimate a</a:t>
+              <a:t>badly - the worst of the nine.</a:t>
             </a:r>
           </a:p>
         </p:txBody>
@@ -4369,7 +4469,7 @@
         </p:nvSpPr>
         <p:spPr>
           <a:xfrm>
-            <a:off x="6217920" y="4224528"/>
+            <a:off x="6309360" y="4782312"/>
             <a:ext cx="5394960" cy="411480"/>
           </a:xfrm>
           <a:prstGeom prst="rect">
@@ -4384,12 +4484,12 @@
           <a:lstStyle/>
           <a:p>
             <a:r>
-              <a:rPr sz="1500" b="0">
-                <a:solidFill>
-                  <a:srgbClr val="55606B"/>
-                </a:solidFill>
-              </a:rPr>
-              <a:t>prototype. Helpful once 200 make it stable.</a:t>
+              <a:rPr sz="1500" b="1">
+                <a:solidFill>
+                  <a:srgbClr val="0E141B"/>
+                </a:solidFill>
+              </a:rPr>
+              <a:t>Both compress 60 dimensions into 3-4 and</a:t>
             </a:r>
           </a:p>
         </p:txBody>
@@ -4402,7 +4502,7 @@
         </p:nvSpPr>
         <p:spPr>
           <a:xfrm>
-            <a:off x="6217920" y="4992624"/>
+            <a:off x="6309360" y="5184648"/>
             <a:ext cx="5394960" cy="411480"/>
           </a:xfrm>
           <a:prstGeom prst="rect">
@@ -4422,40 +4522,7 @@
                   <a:srgbClr val="0E141B"/>
                 </a:solidFill>
               </a:rPr>
-              <a:t>This also explains the LDA failure: rank-3</a:t>
-            </a:r>
-          </a:p>
-        </p:txBody>
-      </p:sp>
-      <p:sp>
-        <p:nvSpPr>
-          <p:cNvPr id="13" name="TextBox 12"/>
-          <p:cNvSpPr txBox="1"/>
-          <p:nvPr/>
-        </p:nvSpPr>
-        <p:spPr>
-          <a:xfrm>
-            <a:off x="6217920" y="5376672"/>
-            <a:ext cx="5394960" cy="411480"/>
-          </a:xfrm>
-          <a:prstGeom prst="rect">
-            <a:avLst/>
-          </a:prstGeom>
-          <a:noFill/>
-        </p:spPr>
-        <p:txBody>
-          <a:bodyPr wrap="square">
-            <a:spAutoFit/>
-          </a:bodyPr>
-          <a:lstStyle/>
-          <a:p>
-            <a:r>
-              <a:rPr sz="1500" b="1">
-                <a:solidFill>
-                  <a:srgbClr val="0E141B"/>
-                </a:solidFill>
-              </a:rPr>
-              <a:t>collapse, not useless supervision.</a:t>
+              <a:t>discard what Amsterdam needs.</a:t>
             </a:r>
           </a:p>
         </p:txBody>
@@ -4506,7 +4573,7 @@
                   <a:srgbClr val="0E141B"/>
                 </a:solidFill>
               </a:rPr>
-              <a:t>We found a 70-day seasonal offset - and tested it</a:t>
+              <a:t>The ranking depends on the label budget</a:t>
             </a:r>
           </a:p>
         </p:txBody>
@@ -4539,7 +4606,7 @@
                   <a:srgbClr val="55606B"/>
                 </a:solidFill>
               </a:rPr>
-              <a:t>A hypothesis that did not pan out, and why that is still a result</a:t>
+              <a:t>Same transform, opposite verdict</a:t>
             </a:r>
           </a:p>
         </p:txBody>
@@ -4580,7 +4647,7 @@
       </p:sp>
       <p:pic>
         <p:nvPicPr>
-          <p:cNvPr id="5" name="Picture 4" descr="fig7_season_offset.png"/>
+          <p:cNvPr id="5" name="Picture 4" descr="fig4_budget_dependence.png"/>
           <p:cNvPicPr>
             <a:picLocks noChangeAspect="1"/>
           </p:cNvPicPr>
@@ -4595,7 +4662,7 @@
         <p:spPr>
           <a:xfrm>
             <a:off x="548640" y="1783080"/>
-            <a:ext cx="6696241" cy="4206240"/>
+            <a:ext cx="7982299" cy="4297680"/>
           </a:xfrm>
           <a:prstGeom prst="rect">
             <a:avLst/>
@@ -4610,27 +4677,27 @@
         </p:nvSpPr>
         <p:spPr>
           <a:xfrm>
-            <a:off x="5394960" y="1828800"/>
-            <a:ext cx="6400800" cy="411480"/>
-          </a:xfrm>
-          <a:prstGeom prst="rect">
-            <a:avLst/>
-          </a:prstGeom>
-          <a:noFill/>
-        </p:spPr>
-        <p:txBody>
-          <a:bodyPr wrap="square">
-            <a:spAutoFit/>
-          </a:bodyPr>
-          <a:lstStyle/>
-          <a:p>
-            <a:r>
-              <a:rPr sz="1300" b="1">
+            <a:off x="6217920" y="1920240"/>
+            <a:ext cx="5394960" cy="411480"/>
+          </a:xfrm>
+          <a:prstGeom prst="rect">
+            <a:avLst/>
+          </a:prstGeom>
+          <a:noFill/>
+        </p:spPr>
+        <p:txBody>
+          <a:bodyPr wrap="square">
+            <a:spAutoFit/>
+          </a:bodyPr>
+          <a:lstStyle/>
+          <a:p>
+            <a:r>
+              <a:rPr sz="1500" b="1">
                 <a:solidFill>
                   <a:srgbClr val="0E141B"/>
                 </a:solidFill>
               </a:rPr>
-              <a:t>Madrid's median observation is day 175. Amsterdam's is 105.</a:t>
+              <a:t>Within-class whitening:</a:t>
             </a:r>
           </a:p>
         </p:txBody>
@@ -4643,27 +4710,27 @@
         </p:nvSpPr>
         <p:spPr>
           <a:xfrm>
-            <a:off x="5394960" y="2139696"/>
-            <a:ext cx="6400800" cy="411480"/>
-          </a:xfrm>
-          <a:prstGeom prst="rect">
-            <a:avLst/>
-          </a:prstGeom>
-          <a:noFill/>
-        </p:spPr>
-        <p:txBody>
-          <a:bodyPr wrap="square">
-            <a:spAutoFit/>
-          </a:bodyPr>
-          <a:lstStyle/>
-          <a:p>
-            <a:r>
-              <a:rPr sz="1300" b="0">
-                <a:solidFill>
-                  <a:srgbClr val="55606B"/>
-                </a:solidFill>
-              </a:rPr>
-              <a:t>June-August share: Madrid 48.3%, Amsterdam 20.5%.</a:t>
+            <a:off x="6217920" y="2304288"/>
+            <a:ext cx="5394960" cy="411480"/>
+          </a:xfrm>
+          <a:prstGeom prst="rect">
+            <a:avLst/>
+          </a:prstGeom>
+          <a:noFill/>
+        </p:spPr>
+        <p:txBody>
+          <a:bodyPr wrap="square">
+            <a:spAutoFit/>
+          </a:bodyPr>
+          <a:lstStyle/>
+          <a:p>
+            <a:r>
+              <a:rPr sz="1500" b="0">
+                <a:solidFill>
+                  <a:srgbClr val="55606B"/>
+                </a:solidFill>
+              </a:rPr>
+              <a:t>        -0.0218 at 5 shots</a:t>
             </a:r>
           </a:p>
         </p:txBody>
@@ -4676,27 +4743,27 @@
         </p:nvSpPr>
         <p:spPr>
           <a:xfrm>
-            <a:off x="5394960" y="2450592"/>
-            <a:ext cx="6400800" cy="411480"/>
-          </a:xfrm>
-          <a:prstGeom prst="rect">
-            <a:avLst/>
-          </a:prstGeom>
-          <a:noFill/>
-        </p:spPr>
-        <p:txBody>
-          <a:bodyPr wrap="square">
-            <a:spAutoFit/>
-          </a:bodyPr>
-          <a:lstStyle/>
-          <a:p>
-            <a:r>
-              <a:rPr sz="1300" b="0">
-                <a:solidFill>
-                  <a:srgbClr val="55606B"/>
-                </a:solidFill>
-              </a:rPr>
-              <a:t>So part of the apparent domain shift is phenology, not architecture.</a:t>
+            <a:off x="6217920" y="2688336"/>
+            <a:ext cx="5394960" cy="411480"/>
+          </a:xfrm>
+          <a:prstGeom prst="rect">
+            <a:avLst/>
+          </a:prstGeom>
+          <a:noFill/>
+        </p:spPr>
+        <p:txBody>
+          <a:bodyPr wrap="square">
+            <a:spAutoFit/>
+          </a:bodyPr>
+          <a:lstStyle/>
+          <a:p>
+            <a:r>
+              <a:rPr sz="1500" b="0">
+                <a:solidFill>
+                  <a:srgbClr val="55606B"/>
+                </a:solidFill>
+              </a:rPr>
+              <a:t>        +0.0090 at 200 shots</a:t>
             </a:r>
           </a:p>
         </p:txBody>
@@ -4709,27 +4776,27 @@
         </p:nvSpPr>
         <p:spPr>
           <a:xfrm>
-            <a:off x="5394960" y="2761488"/>
-            <a:ext cx="6400800" cy="411480"/>
-          </a:xfrm>
-          <a:prstGeom prst="rect">
-            <a:avLst/>
-          </a:prstGeom>
-          <a:noFill/>
-        </p:spPr>
-        <p:txBody>
-          <a:bodyPr wrap="square">
-            <a:spAutoFit/>
-          </a:bodyPr>
-          <a:lstStyle/>
-          <a:p>
-            <a:r>
-              <a:rPr sz="1300" b="0">
-                <a:solidFill>
-                  <a:srgbClr val="55606B"/>
-                </a:solidFill>
-              </a:rPr>
-              <a:t>The starter never uses the day-of-year column at all.</a:t>
+            <a:off x="6217920" y="3456432"/>
+            <a:ext cx="5394960" cy="411480"/>
+          </a:xfrm>
+          <a:prstGeom prst="rect">
+            <a:avLst/>
+          </a:prstGeom>
+          <a:noFill/>
+        </p:spPr>
+        <p:txBody>
+          <a:bodyPr wrap="square">
+            <a:spAutoFit/>
+          </a:bodyPr>
+          <a:lstStyle/>
+          <a:p>
+            <a:r>
+              <a:rPr sz="1500" b="0">
+                <a:solidFill>
+                  <a:srgbClr val="55606B"/>
+                </a:solidFill>
+              </a:rPr>
+              <a:t>Whitening amplifies low-variance directions.</a:t>
             </a:r>
           </a:p>
         </p:txBody>
@@ -4742,258 +4809,126 @@
         </p:nvSpPr>
         <p:spPr>
           <a:xfrm>
-            <a:off x="5394960" y="3383280"/>
-            <a:ext cx="6400800" cy="411480"/>
-          </a:xfrm>
-          <a:prstGeom prst="rect">
-            <a:avLst/>
-          </a:prstGeom>
-          <a:noFill/>
-        </p:spPr>
-        <p:txBody>
-          <a:bodyPr wrap="square">
-            <a:spAutoFit/>
-          </a:bodyPr>
-          <a:lstStyle/>
-          <a:p>
-            <a:r>
-              <a:rPr sz="1300" b="1">
+            <a:off x="6217920" y="3840480"/>
+            <a:ext cx="5394960" cy="411480"/>
+          </a:xfrm>
+          <a:prstGeom prst="rect">
+            <a:avLst/>
+          </a:prstGeom>
+          <a:noFill/>
+        </p:spPr>
+        <p:txBody>
+          <a:bodyPr wrap="square">
+            <a:spAutoFit/>
+          </a:bodyPr>
+          <a:lstStyle/>
+          <a:p>
+            <a:r>
+              <a:rPr sz="1500" b="0">
+                <a:solidFill>
+                  <a:srgbClr val="55606B"/>
+                </a:solidFill>
+              </a:rPr>
+              <a:t>Destructive when 5 points must estimate a</a:t>
+            </a:r>
+          </a:p>
+        </p:txBody>
+      </p:sp>
+      <p:sp>
+        <p:nvSpPr>
+          <p:cNvPr id="11" name="TextBox 10"/>
+          <p:cNvSpPr txBox="1"/>
+          <p:nvPr/>
+        </p:nvSpPr>
+        <p:spPr>
+          <a:xfrm>
+            <a:off x="6217920" y="4224528"/>
+            <a:ext cx="5394960" cy="411480"/>
+          </a:xfrm>
+          <a:prstGeom prst="rect">
+            <a:avLst/>
+          </a:prstGeom>
+          <a:noFill/>
+        </p:spPr>
+        <p:txBody>
+          <a:bodyPr wrap="square">
+            <a:spAutoFit/>
+          </a:bodyPr>
+          <a:lstStyle/>
+          <a:p>
+            <a:r>
+              <a:rPr sz="1500" b="0">
+                <a:solidFill>
+                  <a:srgbClr val="55606B"/>
+                </a:solidFill>
+              </a:rPr>
+              <a:t>prototype. Helpful once 200 make it stable.</a:t>
+            </a:r>
+          </a:p>
+        </p:txBody>
+      </p:sp>
+      <p:sp>
+        <p:nvSpPr>
+          <p:cNvPr id="12" name="TextBox 11"/>
+          <p:cNvSpPr txBox="1"/>
+          <p:nvPr/>
+        </p:nvSpPr>
+        <p:spPr>
+          <a:xfrm>
+            <a:off x="6217920" y="4992624"/>
+            <a:ext cx="5394960" cy="411480"/>
+          </a:xfrm>
+          <a:prstGeom prst="rect">
+            <a:avLst/>
+          </a:prstGeom>
+          <a:noFill/>
+        </p:spPr>
+        <p:txBody>
+          <a:bodyPr wrap="square">
+            <a:spAutoFit/>
+          </a:bodyPr>
+          <a:lstStyle/>
+          <a:p>
+            <a:r>
+              <a:rPr sz="1500" b="1">
                 <a:solidFill>
                   <a:srgbClr val="0E141B"/>
                 </a:solidFill>
               </a:rPr>
-              <a:t>We rebuilt the features to control for it - season-matched spectra,</a:t>
-            </a:r>
-          </a:p>
-        </p:txBody>
-      </p:sp>
-      <p:sp>
-        <p:nvSpPr>
-          <p:cNvPr id="11" name="TextBox 10"/>
-          <p:cNvSpPr txBox="1"/>
-          <p:nvPr/>
-        </p:nvSpPr>
-        <p:spPr>
-          <a:xfrm>
-            <a:off x="5394960" y="3694176"/>
-            <a:ext cx="6400800" cy="411480"/>
-          </a:xfrm>
-          <a:prstGeom prst="rect">
-            <a:avLst/>
-          </a:prstGeom>
-          <a:noFill/>
-        </p:spPr>
-        <p:txBody>
-          <a:bodyPr wrap="square">
-            <a:spAutoFit/>
-          </a:bodyPr>
-          <a:lstStyle/>
-          <a:p>
-            <a:r>
-              <a:rPr sz="1300" b="0">
-                <a:solidFill>
-                  <a:srgbClr val="55606B"/>
-                </a:solidFill>
-              </a:rPr>
-              <a:t>coverage restored, observation density, label-free change timing. 94 features.</a:t>
-            </a:r>
-          </a:p>
-        </p:txBody>
-      </p:sp>
-      <p:sp>
-        <p:nvSpPr>
-          <p:cNvPr id="12" name="TextBox 11"/>
-          <p:cNvSpPr txBox="1"/>
-          <p:nvPr/>
-        </p:nvSpPr>
-        <p:spPr>
-          <a:xfrm>
-            <a:off x="5394960" y="4315968"/>
-            <a:ext cx="6400800" cy="411480"/>
-          </a:xfrm>
-          <a:prstGeom prst="rect">
-            <a:avLst/>
-          </a:prstGeom>
-          <a:noFill/>
-        </p:spPr>
-        <p:txBody>
-          <a:bodyPr wrap="square">
-            <a:spAutoFit/>
-          </a:bodyPr>
-          <a:lstStyle/>
-          <a:p>
-            <a:r>
-              <a:rPr sz="1300" b="1">
+              <a:t>This also explains the LDA failure: rank-3</a:t>
+            </a:r>
+          </a:p>
+        </p:txBody>
+      </p:sp>
+      <p:sp>
+        <p:nvSpPr>
+          <p:cNvPr id="13" name="TextBox 12"/>
+          <p:cNvSpPr txBox="1"/>
+          <p:nvPr/>
+        </p:nvSpPr>
+        <p:spPr>
+          <a:xfrm>
+            <a:off x="6217920" y="5376672"/>
+            <a:ext cx="5394960" cy="411480"/>
+          </a:xfrm>
+          <a:prstGeom prst="rect">
+            <a:avLst/>
+          </a:prstGeom>
+          <a:noFill/>
+        </p:spPr>
+        <p:txBody>
+          <a:bodyPr wrap="square">
+            <a:spAutoFit/>
+          </a:bodyPr>
+          <a:lstStyle/>
+          <a:p>
+            <a:r>
+              <a:rPr sz="1500" b="1">
                 <a:solidFill>
                   <a:srgbClr val="0E141B"/>
                 </a:solidFill>
               </a:rPr>
-              <a:t>It did not help. +0.0001 on selection; slightly worse on audit.</a:t>
-            </a:r>
-          </a:p>
-        </p:txBody>
-      </p:sp>
-      <p:sp>
-        <p:nvSpPr>
-          <p:cNvPr id="13" name="TextBox 12"/>
-          <p:cNvSpPr txBox="1"/>
-          <p:nvPr/>
-        </p:nvSpPr>
-        <p:spPr>
-          <a:xfrm>
-            <a:off x="5394960" y="4626864"/>
-            <a:ext cx="6400800" cy="411480"/>
-          </a:xfrm>
-          <a:prstGeom prst="rect">
-            <a:avLst/>
-          </a:prstGeom>
-          <a:noFill/>
-        </p:spPr>
-        <p:txBody>
-          <a:bodyPr wrap="square">
-            <a:spAutoFit/>
-          </a:bodyPr>
-          <a:lstStyle/>
-          <a:p>
-            <a:r>
-              <a:rPr sz="1300" b="0">
-                <a:solidFill>
-                  <a:srgbClr val="55606B"/>
-                </a:solidFill>
-              </a:rPr>
-              <a:t>The new features hold 29% of importance across 38% of the columns -</a:t>
-            </a:r>
-          </a:p>
-        </p:txBody>
-      </p:sp>
-      <p:sp>
-        <p:nvSpPr>
-          <p:cNvPr id="14" name="TextBox 13"/>
-          <p:cNvSpPr txBox="1"/>
-          <p:nvPr/>
-        </p:nvSpPr>
-        <p:spPr>
-          <a:xfrm>
-            <a:off x="5394960" y="4937760"/>
-            <a:ext cx="6400800" cy="411480"/>
-          </a:xfrm>
-          <a:prstGeom prst="rect">
-            <a:avLst/>
-          </a:prstGeom>
-          <a:noFill/>
-        </p:spPr>
-        <p:txBody>
-          <a:bodyPr wrap="square">
-            <a:spAutoFit/>
-          </a:bodyPr>
-          <a:lstStyle/>
-          <a:p>
-            <a:r>
-              <a:rPr sz="1300" b="0">
-                <a:solidFill>
-                  <a:srgbClr val="55606B"/>
-                </a:solidFill>
-              </a:rPr>
-              <a:t>informative but dilutive. Going 60 to 94 dimensions makes prototype</a:t>
-            </a:r>
-          </a:p>
-        </p:txBody>
-      </p:sp>
-      <p:sp>
-        <p:nvSpPr>
-          <p:cNvPr id="15" name="TextBox 14"/>
-          <p:cNvSpPr txBox="1"/>
-          <p:nvPr/>
-        </p:nvSpPr>
-        <p:spPr>
-          <a:xfrm>
-            <a:off x="5394960" y="5248656"/>
-            <a:ext cx="6400800" cy="411480"/>
-          </a:xfrm>
-          <a:prstGeom prst="rect">
-            <a:avLst/>
-          </a:prstGeom>
-          <a:noFill/>
-        </p:spPr>
-        <p:txBody>
-          <a:bodyPr wrap="square">
-            <a:spAutoFit/>
-          </a:bodyPr>
-          <a:lstStyle/>
-          <a:p>
-            <a:r>
-              <a:rPr sz="1300" b="0">
-                <a:solidFill>
-                  <a:srgbClr val="55606B"/>
-                </a:solidFill>
-              </a:rPr>
-              <a:t>estimation noisier, which is why it loses most at 5 shots.</a:t>
-            </a:r>
-          </a:p>
-        </p:txBody>
-      </p:sp>
-      <p:sp>
-        <p:nvSpPr>
-          <p:cNvPr id="16" name="TextBox 15"/>
-          <p:cNvSpPr txBox="1"/>
-          <p:nvPr/>
-        </p:nvSpPr>
-        <p:spPr>
-          <a:xfrm>
-            <a:off x="5394960" y="5870448"/>
-            <a:ext cx="6400800" cy="411480"/>
-          </a:xfrm>
-          <a:prstGeom prst="rect">
-            <a:avLst/>
-          </a:prstGeom>
-          <a:noFill/>
-        </p:spPr>
-        <p:txBody>
-          <a:bodyPr wrap="square">
-            <a:spAutoFit/>
-          </a:bodyPr>
-          <a:lstStyle/>
-          <a:p>
-            <a:r>
-              <a:rPr sz="1300" b="1">
-                <a:solidFill>
-                  <a:srgbClr val="0E141B"/>
-                </a:solidFill>
-              </a:rPr>
-              <a:t>Same lesson as the whitening result: in the low-data regime, extra</a:t>
-            </a:r>
-          </a:p>
-        </p:txBody>
-      </p:sp>
-      <p:sp>
-        <p:nvSpPr>
-          <p:cNvPr id="17" name="TextBox 16"/>
-          <p:cNvSpPr txBox="1"/>
-          <p:nvPr/>
-        </p:nvSpPr>
-        <p:spPr>
-          <a:xfrm>
-            <a:off x="5394960" y="6181344"/>
-            <a:ext cx="6400800" cy="411480"/>
-          </a:xfrm>
-          <a:prstGeom prst="rect">
-            <a:avLst/>
-          </a:prstGeom>
-          <a:noFill/>
-        </p:spPr>
-        <p:txBody>
-          <a:bodyPr wrap="square">
-            <a:spAutoFit/>
-          </a:bodyPr>
-          <a:lstStyle/>
-          <a:p>
-            <a:r>
-              <a:rPr sz="1300" b="1">
-                <a:solidFill>
-                  <a:srgbClr val="0E141B"/>
-                </a:solidFill>
-              </a:rPr>
-              <a:t>dimensions cost more in estimation error than they add in signal.</a:t>
+              <a:t>collapse, not useless supervision.</a:t>
             </a:r>
           </a:p>
         </p:txBody>
@@ -5044,7 +4979,7 @@
                   <a:srgbClr val="0E141B"/>
                 </a:solidFill>
               </a:rPr>
-              <a:t>Reading the numbers honestly</a:t>
+              <a:t>We found a 70-day seasonal offset - and tested it</a:t>
             </a:r>
           </a:p>
         </p:txBody>
@@ -5077,7 +5012,7 @@
                   <a:srgbClr val="55606B"/>
                 </a:solidFill>
               </a:rPr>
-              <a:t>What we claim, and what we do not</a:t>
+              <a:t>A hypothesis that did not pan out, and why that is still a result</a:t>
             </a:r>
           </a:p>
         </p:txBody>
@@ -5118,7 +5053,7 @@
       </p:sp>
       <p:pic>
         <p:nvPicPr>
-          <p:cNvPr id="5" name="Picture 4" descr="fig2_transfer_benefit.png"/>
+          <p:cNvPr id="5" name="Picture 4" descr="fig7_season_offset.png"/>
           <p:cNvPicPr>
             <a:picLocks noChangeAspect="1"/>
           </p:cNvPicPr>
@@ -5132,8 +5067,8 @@
         </p:blipFill>
         <p:spPr>
           <a:xfrm>
-            <a:off x="548640" y="1920240"/>
-            <a:ext cx="5756868" cy="3474720"/>
+            <a:off x="548640" y="1783080"/>
+            <a:ext cx="6696241" cy="4206240"/>
           </a:xfrm>
           <a:prstGeom prst="rect">
             <a:avLst/>
@@ -5148,27 +5083,27 @@
         </p:nvSpPr>
         <p:spPr>
           <a:xfrm>
-            <a:off x="5394960" y="1874519"/>
-            <a:ext cx="6217920" cy="411480"/>
-          </a:xfrm>
-          <a:prstGeom prst="rect">
-            <a:avLst/>
-          </a:prstGeom>
-          <a:noFill/>
-        </p:spPr>
-        <p:txBody>
-          <a:bodyPr wrap="square">
-            <a:spAutoFit/>
-          </a:bodyPr>
-          <a:lstStyle/>
-          <a:p>
-            <a:r>
-              <a:rPr sz="1500" b="1">
+            <a:off x="5394960" y="1828800"/>
+            <a:ext cx="6400800" cy="411480"/>
+          </a:xfrm>
+          <a:prstGeom prst="rect">
+            <a:avLst/>
+          </a:prstGeom>
+          <a:noFill/>
+        </p:spPr>
+        <p:txBody>
+          <a:bodyPr wrap="square">
+            <a:spAutoFit/>
+          </a:bodyPr>
+          <a:lstStyle/>
+          <a:p>
+            <a:r>
+              <a:rPr sz="1300" b="1">
                 <a:solidFill>
                   <a:srgbClr val="0E141B"/>
                 </a:solidFill>
               </a:rPr>
-              <a:t>The gain is small: +0.002 to +0.007.</a:t>
+              <a:t>Madrid's median observation is day 175. Amsterdam's is 105.</a:t>
             </a:r>
           </a:p>
         </p:txBody>
@@ -5181,27 +5116,27 @@
         </p:nvSpPr>
         <p:spPr>
           <a:xfrm>
-            <a:off x="5394960" y="2258568"/>
-            <a:ext cx="6217920" cy="411480"/>
-          </a:xfrm>
-          <a:prstGeom prst="rect">
-            <a:avLst/>
-          </a:prstGeom>
-          <a:noFill/>
-        </p:spPr>
-        <p:txBody>
-          <a:bodyPr wrap="square">
-            <a:spAutoFit/>
-          </a:bodyPr>
-          <a:lstStyle/>
-          <a:p>
-            <a:r>
-              <a:rPr sz="1500" b="0">
-                <a:solidFill>
-                  <a:srgbClr val="55606B"/>
-                </a:solidFill>
-              </a:rPr>
-              <a:t>The evidence is consistency across matched</a:t>
+            <a:off x="5394960" y="2139696"/>
+            <a:ext cx="6400800" cy="411480"/>
+          </a:xfrm>
+          <a:prstGeom prst="rect">
+            <a:avLst/>
+          </a:prstGeom>
+          <a:noFill/>
+        </p:spPr>
+        <p:txBody>
+          <a:bodyPr wrap="square">
+            <a:spAutoFit/>
+          </a:bodyPr>
+          <a:lstStyle/>
+          <a:p>
+            <a:r>
+              <a:rPr sz="1300" b="0">
+                <a:solidFill>
+                  <a:srgbClr val="55606B"/>
+                </a:solidFill>
+              </a:rPr>
+              <a:t>June-August share: Madrid 48.3%, Amsterdam 20.5%.</a:t>
             </a:r>
           </a:p>
         </p:txBody>
@@ -5214,27 +5149,27 @@
         </p:nvSpPr>
         <p:spPr>
           <a:xfrm>
-            <a:off x="5394960" y="2642615"/>
-            <a:ext cx="6217920" cy="411480"/>
-          </a:xfrm>
-          <a:prstGeom prst="rect">
-            <a:avLst/>
-          </a:prstGeom>
-          <a:noFill/>
-        </p:spPr>
-        <p:txBody>
-          <a:bodyPr wrap="square">
-            <a:spAutoFit/>
-          </a:bodyPr>
-          <a:lstStyle/>
-          <a:p>
-            <a:r>
-              <a:rPr sz="1500" b="0">
-                <a:solidFill>
-                  <a:srgbClr val="55606B"/>
-                </a:solidFill>
-              </a:rPr>
-              <a:t>episodes, not magnitude.</a:t>
+            <a:off x="5394960" y="2450592"/>
+            <a:ext cx="6400800" cy="411480"/>
+          </a:xfrm>
+          <a:prstGeom prst="rect">
+            <a:avLst/>
+          </a:prstGeom>
+          <a:noFill/>
+        </p:spPr>
+        <p:txBody>
+          <a:bodyPr wrap="square">
+            <a:spAutoFit/>
+          </a:bodyPr>
+          <a:lstStyle/>
+          <a:p>
+            <a:r>
+              <a:rPr sz="1300" b="0">
+                <a:solidFill>
+                  <a:srgbClr val="55606B"/>
+                </a:solidFill>
+              </a:rPr>
+              <a:t>So part of the apparent domain shift is phenology, not architecture.</a:t>
             </a:r>
           </a:p>
         </p:txBody>
@@ -5247,126 +5182,126 @@
         </p:nvSpPr>
         <p:spPr>
           <a:xfrm>
-            <a:off x="5394960" y="3410711"/>
-            <a:ext cx="6217920" cy="411480"/>
-          </a:xfrm>
-          <a:prstGeom prst="rect">
-            <a:avLst/>
-          </a:prstGeom>
-          <a:noFill/>
-        </p:spPr>
-        <p:txBody>
-          <a:bodyPr wrap="square">
-            <a:spAutoFit/>
-          </a:bodyPr>
-          <a:lstStyle/>
-          <a:p>
-            <a:r>
-              <a:rPr sz="1500" b="1">
+            <a:off x="5394960" y="2761488"/>
+            <a:ext cx="6400800" cy="411480"/>
+          </a:xfrm>
+          <a:prstGeom prst="rect">
+            <a:avLst/>
+          </a:prstGeom>
+          <a:noFill/>
+        </p:spPr>
+        <p:txBody>
+          <a:bodyPr wrap="square">
+            <a:spAutoFit/>
+          </a:bodyPr>
+          <a:lstStyle/>
+          <a:p>
+            <a:r>
+              <a:rPr sz="1300" b="0">
+                <a:solidFill>
+                  <a:srgbClr val="55606B"/>
+                </a:solidFill>
+              </a:rPr>
+              <a:t>The starter never uses the day-of-year column at all.</a:t>
+            </a:r>
+          </a:p>
+        </p:txBody>
+      </p:sp>
+      <p:sp>
+        <p:nvSpPr>
+          <p:cNvPr id="10" name="TextBox 9"/>
+          <p:cNvSpPr txBox="1"/>
+          <p:nvPr/>
+        </p:nvSpPr>
+        <p:spPr>
+          <a:xfrm>
+            <a:off x="5394960" y="3383280"/>
+            <a:ext cx="6400800" cy="411480"/>
+          </a:xfrm>
+          <a:prstGeom prst="rect">
+            <a:avLst/>
+          </a:prstGeom>
+          <a:noFill/>
+        </p:spPr>
+        <p:txBody>
+          <a:bodyPr wrap="square">
+            <a:spAutoFit/>
+          </a:bodyPr>
+          <a:lstStyle/>
+          <a:p>
+            <a:r>
+              <a:rPr sz="1300" b="1">
                 <a:solidFill>
                   <a:srgbClr val="0E141B"/>
                 </a:solidFill>
               </a:rPr>
-              <a:t>Error bars are spreads, not confidence intervals.</a:t>
-            </a:r>
-          </a:p>
-        </p:txBody>
-      </p:sp>
-      <p:sp>
-        <p:nvSpPr>
-          <p:cNvPr id="10" name="TextBox 9"/>
-          <p:cNvSpPr txBox="1"/>
-          <p:nvPr/>
-        </p:nvSpPr>
-        <p:spPr>
-          <a:xfrm>
-            <a:off x="5394960" y="3794760"/>
-            <a:ext cx="6217920" cy="411480"/>
-          </a:xfrm>
-          <a:prstGeom prst="rect">
-            <a:avLst/>
-          </a:prstGeom>
-          <a:noFill/>
-        </p:spPr>
-        <p:txBody>
-          <a:bodyPr wrap="square">
-            <a:spAutoFit/>
-          </a:bodyPr>
-          <a:lstStyle/>
-          <a:p>
-            <a:r>
-              <a:rPr sz="1500" b="1">
+              <a:t>We rebuilt the features to control for it - season-matched spectra,</a:t>
+            </a:r>
+          </a:p>
+        </p:txBody>
+      </p:sp>
+      <p:sp>
+        <p:nvSpPr>
+          <p:cNvPr id="11" name="TextBox 10"/>
+          <p:cNvSpPr txBox="1"/>
+          <p:nvPr/>
+        </p:nvSpPr>
+        <p:spPr>
+          <a:xfrm>
+            <a:off x="5394960" y="3694176"/>
+            <a:ext cx="6400800" cy="411480"/>
+          </a:xfrm>
+          <a:prstGeom prst="rect">
+            <a:avLst/>
+          </a:prstGeom>
+          <a:noFill/>
+        </p:spPr>
+        <p:txBody>
+          <a:bodyPr wrap="square">
+            <a:spAutoFit/>
+          </a:bodyPr>
+          <a:lstStyle/>
+          <a:p>
+            <a:r>
+              <a:rPr sz="1300" b="0">
+                <a:solidFill>
+                  <a:srgbClr val="55606B"/>
+                </a:solidFill>
+              </a:rPr>
+              <a:t>coverage restored, observation density, label-free change timing. 94 features.</a:t>
+            </a:r>
+          </a:p>
+        </p:txBody>
+      </p:sp>
+      <p:sp>
+        <p:nvSpPr>
+          <p:cNvPr id="12" name="TextBox 11"/>
+          <p:cNvSpPr txBox="1"/>
+          <p:nvPr/>
+        </p:nvSpPr>
+        <p:spPr>
+          <a:xfrm>
+            <a:off x="5394960" y="4315968"/>
+            <a:ext cx="6400800" cy="411480"/>
+          </a:xfrm>
+          <a:prstGeom prst="rect">
+            <a:avLst/>
+          </a:prstGeom>
+          <a:noFill/>
+        </p:spPr>
+        <p:txBody>
+          <a:bodyPr wrap="square">
+            <a:spAutoFit/>
+          </a:bodyPr>
+          <a:lstStyle/>
+          <a:p>
+            <a:r>
+              <a:rPr sz="1300" b="1">
                 <a:solidFill>
                   <a:srgbClr val="0E141B"/>
                 </a:solidFill>
               </a:rPr>
-              <a:t>Confusion diagonals are recall, not F1.</a:t>
-            </a:r>
-          </a:p>
-        </p:txBody>
-      </p:sp>
-      <p:sp>
-        <p:nvSpPr>
-          <p:cNvPr id="11" name="TextBox 10"/>
-          <p:cNvSpPr txBox="1"/>
-          <p:nvPr/>
-        </p:nvSpPr>
-        <p:spPr>
-          <a:xfrm>
-            <a:off x="5394960" y="4178808"/>
-            <a:ext cx="6217920" cy="411480"/>
-          </a:xfrm>
-          <a:prstGeom prst="rect">
-            <a:avLst/>
-          </a:prstGeom>
-          <a:noFill/>
-        </p:spPr>
-        <p:txBody>
-          <a:bodyPr wrap="square">
-            <a:spAutoFit/>
-          </a:bodyPr>
-          <a:lstStyle/>
-          <a:p>
-            <a:r>
-              <a:rPr sz="1500" b="0">
-                <a:solidFill>
-                  <a:srgbClr val="55606B"/>
-                </a:solidFill>
-              </a:rPr>
-              <a:t>Accuracy 0.4496 exceeds macro F1 0.4433 on</a:t>
-            </a:r>
-          </a:p>
-        </p:txBody>
-      </p:sp>
-      <p:sp>
-        <p:nvSpPr>
-          <p:cNvPr id="12" name="TextBox 11"/>
-          <p:cNvSpPr txBox="1"/>
-          <p:nvPr/>
-        </p:nvSpPr>
-        <p:spPr>
-          <a:xfrm>
-            <a:off x="5394960" y="4562856"/>
-            <a:ext cx="6217920" cy="411480"/>
-          </a:xfrm>
-          <a:prstGeom prst="rect">
-            <a:avLst/>
-          </a:prstGeom>
-          <a:noFill/>
-        </p:spPr>
-        <p:txBody>
-          <a:bodyPr wrap="square">
-            <a:spAutoFit/>
-          </a:bodyPr>
-          <a:lstStyle/>
-          <a:p>
-            <a:r>
-              <a:rPr sz="1500" b="0">
-                <a:solidFill>
-                  <a:srgbClr val="55606B"/>
-                </a:solidFill>
-              </a:rPr>
-              <a:t>zero-shot - accuracy would have flattered us.</a:t>
+              <a:t>It did not help. +0.0001 on selection; slightly worse on audit.</a:t>
             </a:r>
           </a:p>
         </p:txBody>
@@ -5379,60 +5314,159 @@
         </p:nvSpPr>
         <p:spPr>
           <a:xfrm>
-            <a:off x="5394960" y="5330952"/>
-            <a:ext cx="6217920" cy="411480"/>
-          </a:xfrm>
-          <a:prstGeom prst="rect">
-            <a:avLst/>
-          </a:prstGeom>
-          <a:noFill/>
-        </p:spPr>
-        <p:txBody>
-          <a:bodyPr wrap="square">
-            <a:spAutoFit/>
-          </a:bodyPr>
-          <a:lstStyle/>
-          <a:p>
-            <a:r>
-              <a:rPr sz="1500" b="1">
+            <a:off x="5394960" y="4626864"/>
+            <a:ext cx="6400800" cy="411480"/>
+          </a:xfrm>
+          <a:prstGeom prst="rect">
+            <a:avLst/>
+          </a:prstGeom>
+          <a:noFill/>
+        </p:spPr>
+        <p:txBody>
+          <a:bodyPr wrap="square">
+            <a:spAutoFit/>
+          </a:bodyPr>
+          <a:lstStyle/>
+          <a:p>
+            <a:r>
+              <a:rPr sz="1300" b="0">
+                <a:solidFill>
+                  <a:srgbClr val="55606B"/>
+                </a:solidFill>
+              </a:rPr>
+              <a:t>The new features hold 29% of importance across 38% of the columns -</a:t>
+            </a:r>
+          </a:p>
+        </p:txBody>
+      </p:sp>
+      <p:sp>
+        <p:nvSpPr>
+          <p:cNvPr id="14" name="TextBox 13"/>
+          <p:cNvSpPr txBox="1"/>
+          <p:nvPr/>
+        </p:nvSpPr>
+        <p:spPr>
+          <a:xfrm>
+            <a:off x="5394960" y="4937760"/>
+            <a:ext cx="6400800" cy="411480"/>
+          </a:xfrm>
+          <a:prstGeom prst="rect">
+            <a:avLst/>
+          </a:prstGeom>
+          <a:noFill/>
+        </p:spPr>
+        <p:txBody>
+          <a:bodyPr wrap="square">
+            <a:spAutoFit/>
+          </a:bodyPr>
+          <a:lstStyle/>
+          <a:p>
+            <a:r>
+              <a:rPr sz="1300" b="0">
+                <a:solidFill>
+                  <a:srgbClr val="55606B"/>
+                </a:solidFill>
+              </a:rPr>
+              <a:t>informative but dilutive. Going 60 to 94 dimensions makes prototype</a:t>
+            </a:r>
+          </a:p>
+        </p:txBody>
+      </p:sp>
+      <p:sp>
+        <p:nvSpPr>
+          <p:cNvPr id="15" name="TextBox 14"/>
+          <p:cNvSpPr txBox="1"/>
+          <p:nvPr/>
+        </p:nvSpPr>
+        <p:spPr>
+          <a:xfrm>
+            <a:off x="5394960" y="5248656"/>
+            <a:ext cx="6400800" cy="411480"/>
+          </a:xfrm>
+          <a:prstGeom prst="rect">
+            <a:avLst/>
+          </a:prstGeom>
+          <a:noFill/>
+        </p:spPr>
+        <p:txBody>
+          <a:bodyPr wrap="square">
+            <a:spAutoFit/>
+          </a:bodyPr>
+          <a:lstStyle/>
+          <a:p>
+            <a:r>
+              <a:rPr sz="1300" b="0">
+                <a:solidFill>
+                  <a:srgbClr val="55606B"/>
+                </a:solidFill>
+              </a:rPr>
+              <a:t>estimation noisier, which is why it loses most at 5 shots.</a:t>
+            </a:r>
+          </a:p>
+        </p:txBody>
+      </p:sp>
+      <p:sp>
+        <p:nvSpPr>
+          <p:cNvPr id="16" name="TextBox 15"/>
+          <p:cNvSpPr txBox="1"/>
+          <p:nvPr/>
+        </p:nvSpPr>
+        <p:spPr>
+          <a:xfrm>
+            <a:off x="5394960" y="5870448"/>
+            <a:ext cx="6400800" cy="411480"/>
+          </a:xfrm>
+          <a:prstGeom prst="rect">
+            <a:avLst/>
+          </a:prstGeom>
+          <a:noFill/>
+        </p:spPr>
+        <p:txBody>
+          <a:bodyPr wrap="square">
+            <a:spAutoFit/>
+          </a:bodyPr>
+          <a:lstStyle/>
+          <a:p>
+            <a:r>
+              <a:rPr sz="1300" b="1">
                 <a:solidFill>
                   <a:srgbClr val="0E141B"/>
                 </a:solidFill>
               </a:rPr>
-              <a:t>Two methods were audited on the first set, so we crown no winner -</a:t>
-            </a:r>
-          </a:p>
-        </p:txBody>
-      </p:sp>
-      <p:sp>
-        <p:nvSpPr>
-          <p:cNvPr id="14" name="TextBox 13"/>
-          <p:cNvSpPr txBox="1"/>
-          <p:nvPr/>
-        </p:nvSpPr>
-        <p:spPr>
-          <a:xfrm>
-            <a:off x="5394960" y="5715000"/>
-            <a:ext cx="6217920" cy="411480"/>
-          </a:xfrm>
-          <a:prstGeom prst="rect">
-            <a:avLst/>
-          </a:prstGeom>
-          <a:noFill/>
-        </p:spPr>
-        <p:txBody>
-          <a:bodyPr wrap="square">
-            <a:spAutoFit/>
-          </a:bodyPr>
-          <a:lstStyle/>
-          <a:p>
-            <a:r>
-              <a:rPr sz="1500" b="1">
+              <a:t>Same lesson as the whitening result: in the low-data regime, extra</a:t>
+            </a:r>
+          </a:p>
+        </p:txBody>
+      </p:sp>
+      <p:sp>
+        <p:nvSpPr>
+          <p:cNvPr id="17" name="TextBox 16"/>
+          <p:cNvSpPr txBox="1"/>
+          <p:nvPr/>
+        </p:nvSpPr>
+        <p:spPr>
+          <a:xfrm>
+            <a:off x="5394960" y="6181344"/>
+            <a:ext cx="6400800" cy="411480"/>
+          </a:xfrm>
+          <a:prstGeom prst="rect">
+            <a:avLst/>
+          </a:prstGeom>
+          <a:noFill/>
+        </p:spPr>
+        <p:txBody>
+          <a:bodyPr wrap="square">
+            <a:spAutoFit/>
+          </a:bodyPr>
+          <a:lstStyle/>
+          <a:p>
+            <a:r>
+              <a:rPr sz="1300" b="1">
                 <a:solidFill>
                   <a:srgbClr val="0E141B"/>
                 </a:solidFill>
               </a:rPr>
-              <a:t>but the headline result replicates on independent episodes.</a:t>
+              <a:t>dimensions cost more in estimation error than they add in signal.</a:t>
             </a:r>
           </a:p>
         </p:txBody>
@@ -5483,7 +5517,7 @@
                   <a:srgbClr val="0E141B"/>
                 </a:solidFill>
               </a:rPr>
-              <a:t>Where it still fails</a:t>
+              <a:t>Reading the numbers honestly</a:t>
             </a:r>
           </a:p>
         </p:txBody>
@@ -5516,7 +5550,7 @@
                   <a:srgbClr val="55606B"/>
                 </a:solidFill>
               </a:rPr>
-              <a:t>Class 2 is the hard one</a:t>
+              <a:t>What we claim, and what we do not</a:t>
             </a:r>
           </a:p>
         </p:txBody>
@@ -5557,7 +5591,7 @@
       </p:sp>
       <p:pic>
         <p:nvPicPr>
-          <p:cNvPr id="5" name="Picture 4" descr="fig5_confusion.png"/>
+          <p:cNvPr id="5" name="Picture 4" descr="fig2_transfer_benefit.png"/>
           <p:cNvPicPr>
             <a:picLocks noChangeAspect="1"/>
           </p:cNvPicPr>
@@ -5571,8 +5605,8 @@
         </p:blipFill>
         <p:spPr>
           <a:xfrm>
-            <a:off x="731520" y="1783080"/>
-            <a:ext cx="4655344" cy="4206240"/>
+            <a:off x="548640" y="1920240"/>
+            <a:ext cx="5756868" cy="3474720"/>
           </a:xfrm>
           <a:prstGeom prst="rect">
             <a:avLst/>
@@ -5587,8 +5621,8 @@
         </p:nvSpPr>
         <p:spPr>
           <a:xfrm>
-            <a:off x="5852160" y="2011680"/>
-            <a:ext cx="5760720" cy="411480"/>
+            <a:off x="5394960" y="1874519"/>
+            <a:ext cx="6217920" cy="411480"/>
           </a:xfrm>
           <a:prstGeom prst="rect">
             <a:avLst/>
@@ -5607,7 +5641,7 @@
                   <a:srgbClr val="0E141B"/>
                 </a:solidFill>
               </a:rPr>
-              <a:t>37% of true Class 2 pixels are predicted Class 1.</a:t>
+              <a:t>The gain is small: +0.002 to +0.007.</a:t>
             </a:r>
           </a:p>
         </p:txBody>
@@ -5620,8 +5654,8 @@
         </p:nvSpPr>
         <p:spPr>
           <a:xfrm>
-            <a:off x="5852160" y="2816352"/>
-            <a:ext cx="5760720" cy="411480"/>
+            <a:off x="5394960" y="2258568"/>
+            <a:ext cx="6217920" cy="411480"/>
           </a:xfrm>
           <a:prstGeom prst="rect">
             <a:avLst/>
@@ -5640,7 +5674,7 @@
                   <a:srgbClr val="55606B"/>
                 </a:solidFill>
               </a:rPr>
-              <a:t>Zero-shot Class 3 was the sharpest failure:</a:t>
+              <a:t>The evidence is consistency across matched</a:t>
             </a:r>
           </a:p>
         </p:txBody>
@@ -5653,8 +5687,8 @@
         </p:nvSpPr>
         <p:spPr>
           <a:xfrm>
-            <a:off x="5852160" y="3218688"/>
-            <a:ext cx="5760720" cy="411480"/>
+            <a:off x="5394960" y="2642615"/>
+            <a:ext cx="6217920" cy="411480"/>
           </a:xfrm>
           <a:prstGeom prst="rect">
             <a:avLst/>
@@ -5673,7 +5707,7 @@
                   <a:srgbClr val="55606B"/>
                 </a:solidFill>
               </a:rPr>
-              <a:t>recall 0.19 against precision 0.77. The Madrid</a:t>
+              <a:t>episodes, not magnitude.</a:t>
             </a:r>
           </a:p>
         </p:txBody>
@@ -5686,8 +5720,74 @@
         </p:nvSpPr>
         <p:spPr>
           <a:xfrm>
-            <a:off x="5852160" y="3621024"/>
-            <a:ext cx="5760720" cy="411480"/>
+            <a:off x="5394960" y="3410711"/>
+            <a:ext cx="6217920" cy="411480"/>
+          </a:xfrm>
+          <a:prstGeom prst="rect">
+            <a:avLst/>
+          </a:prstGeom>
+          <a:noFill/>
+        </p:spPr>
+        <p:txBody>
+          <a:bodyPr wrap="square">
+            <a:spAutoFit/>
+          </a:bodyPr>
+          <a:lstStyle/>
+          <a:p>
+            <a:r>
+              <a:rPr sz="1500" b="1">
+                <a:solidFill>
+                  <a:srgbClr val="0E141B"/>
+                </a:solidFill>
+              </a:rPr>
+              <a:t>Error bars are spreads, not confidence intervals.</a:t>
+            </a:r>
+          </a:p>
+        </p:txBody>
+      </p:sp>
+      <p:sp>
+        <p:nvSpPr>
+          <p:cNvPr id="10" name="TextBox 9"/>
+          <p:cNvSpPr txBox="1"/>
+          <p:nvPr/>
+        </p:nvSpPr>
+        <p:spPr>
+          <a:xfrm>
+            <a:off x="5394960" y="3794760"/>
+            <a:ext cx="6217920" cy="411480"/>
+          </a:xfrm>
+          <a:prstGeom prst="rect">
+            <a:avLst/>
+          </a:prstGeom>
+          <a:noFill/>
+        </p:spPr>
+        <p:txBody>
+          <a:bodyPr wrap="square">
+            <a:spAutoFit/>
+          </a:bodyPr>
+          <a:lstStyle/>
+          <a:p>
+            <a:r>
+              <a:rPr sz="1500" b="1">
+                <a:solidFill>
+                  <a:srgbClr val="0E141B"/>
+                </a:solidFill>
+              </a:rPr>
+              <a:t>Confusion diagonals are recall, not F1.</a:t>
+            </a:r>
+          </a:p>
+        </p:txBody>
+      </p:sp>
+      <p:sp>
+        <p:nvSpPr>
+          <p:cNvPr id="11" name="TextBox 10"/>
+          <p:cNvSpPr txBox="1"/>
+          <p:nvPr/>
+        </p:nvSpPr>
+        <p:spPr>
+          <a:xfrm>
+            <a:off x="5394960" y="4178808"/>
+            <a:ext cx="6217920" cy="411480"/>
           </a:xfrm>
           <a:prstGeom prst="rect">
             <a:avLst/>
@@ -5706,21 +5806,21 @@
                   <a:srgbClr val="55606B"/>
                 </a:solidFill>
               </a:rPr>
-              <a:t>model almost never predicted it, but was usually</a:t>
-            </a:r>
-          </a:p>
-        </p:txBody>
-      </p:sp>
-      <p:sp>
-        <p:nvSpPr>
-          <p:cNvPr id="10" name="TextBox 9"/>
-          <p:cNvSpPr txBox="1"/>
-          <p:nvPr/>
-        </p:nvSpPr>
-        <p:spPr>
-          <a:xfrm>
-            <a:off x="5852160" y="4023360"/>
-            <a:ext cx="5760720" cy="411480"/>
+              <a:t>Accuracy 0.4496 exceeds macro F1 0.4433 on</a:t>
+            </a:r>
+          </a:p>
+        </p:txBody>
+      </p:sp>
+      <p:sp>
+        <p:nvSpPr>
+          <p:cNvPr id="12" name="TextBox 11"/>
+          <p:cNvSpPr txBox="1"/>
+          <p:nvPr/>
+        </p:nvSpPr>
+        <p:spPr>
+          <a:xfrm>
+            <a:off x="5394960" y="4562856"/>
+            <a:ext cx="6217920" cy="411480"/>
           </a:xfrm>
           <a:prstGeom prst="rect">
             <a:avLst/>
@@ -5739,21 +5839,21 @@
                   <a:srgbClr val="55606B"/>
                 </a:solidFill>
               </a:rPr>
-              <a:t>right when it did.</a:t>
-            </a:r>
-          </a:p>
-        </p:txBody>
-      </p:sp>
-      <p:sp>
-        <p:nvSpPr>
-          <p:cNvPr id="11" name="TextBox 10"/>
-          <p:cNvSpPr txBox="1"/>
-          <p:nvPr/>
-        </p:nvSpPr>
-        <p:spPr>
-          <a:xfrm>
-            <a:off x="5852160" y="4828032"/>
-            <a:ext cx="5760720" cy="411480"/>
+              <a:t>zero-shot - accuracy would have flattered us.</a:t>
+            </a:r>
+          </a:p>
+        </p:txBody>
+      </p:sp>
+      <p:sp>
+        <p:nvSpPr>
+          <p:cNvPr id="13" name="TextBox 12"/>
+          <p:cNvSpPr txBox="1"/>
+          <p:nvPr/>
+        </p:nvSpPr>
+        <p:spPr>
+          <a:xfrm>
+            <a:off x="5394960" y="5330952"/>
+            <a:ext cx="6217920" cy="411480"/>
           </a:xfrm>
           <a:prstGeom prst="rect">
             <a:avLst/>
@@ -5772,21 +5872,21 @@
                   <a:srgbClr val="0E141B"/>
                 </a:solidFill>
               </a:rPr>
-              <a:t>Adjacent eras look alike from space. That is a</a:t>
-            </a:r>
-          </a:p>
-        </p:txBody>
-      </p:sp>
-      <p:sp>
-        <p:nvSpPr>
-          <p:cNvPr id="12" name="TextBox 11"/>
-          <p:cNvSpPr txBox="1"/>
-          <p:nvPr/>
-        </p:nvSpPr>
-        <p:spPr>
-          <a:xfrm>
-            <a:off x="5852160" y="5230368"/>
-            <a:ext cx="5760720" cy="411480"/>
+              <a:t>Two methods were audited on the first set, so we crown no winner -</a:t>
+            </a:r>
+          </a:p>
+        </p:txBody>
+      </p:sp>
+      <p:sp>
+        <p:nvSpPr>
+          <p:cNvPr id="14" name="TextBox 13"/>
+          <p:cNvSpPr txBox="1"/>
+          <p:nvPr/>
+        </p:nvSpPr>
+        <p:spPr>
+          <a:xfrm>
+            <a:off x="5394960" y="5715000"/>
+            <a:ext cx="6217920" cy="411480"/>
           </a:xfrm>
           <a:prstGeom prst="rect">
             <a:avLst/>
@@ -5805,7 +5905,7 @@
                   <a:srgbClr val="0E141B"/>
                 </a:solidFill>
               </a:rPr>
-              <a:t>property of the problem, not a bug to tune away.</a:t>
+              <a:t>but the headline result replicates on independent episodes.</a:t>
             </a:r>
           </a:p>
         </p:txBody>
@@ -5856,7 +5956,7 @@
                   <a:srgbClr val="0E141B"/>
                 </a:solidFill>
               </a:rPr>
-              <a:t>Limitations</a:t>
+              <a:t>Where it still fails</a:t>
             </a:r>
           </a:p>
         </p:txBody>
@@ -5889,7 +5989,7 @@
                   <a:srgbClr val="55606B"/>
                 </a:solidFill>
               </a:rPr>
-              <a:t>Stated, not hidden</a:t>
+              <a:t>Class 2 is the hard one</a:t>
             </a:r>
           </a:p>
         </p:txBody>
@@ -5928,68 +6028,59 @@
           </a:p>
         </p:txBody>
       </p:sp>
-      <p:sp>
-        <p:nvSpPr>
-          <p:cNvPr id="5" name="TextBox 4"/>
-          <p:cNvSpPr txBox="1"/>
-          <p:nvPr/>
-        </p:nvSpPr>
-        <p:spPr>
-          <a:xfrm>
-            <a:off x="640080" y="2011680"/>
-            <a:ext cx="10972800" cy="411480"/>
-          </a:xfrm>
-          <a:prstGeom prst="rect">
-            <a:avLst/>
-          </a:prstGeom>
-          <a:noFill/>
-        </p:spPr>
-        <p:txBody>
-          <a:bodyPr wrap="square">
-            <a:spAutoFit/>
-          </a:bodyPr>
-          <a:lstStyle/>
-          <a:p>
-            <a:r>
-              <a:rPr sz="1700" b="1">
+      <p:pic>
+        <p:nvPicPr>
+          <p:cNvPr id="5" name="Picture 4" descr="fig5_confusion.png"/>
+          <p:cNvPicPr>
+            <a:picLocks noChangeAspect="1"/>
+          </p:cNvPicPr>
+          <p:nvPr/>
+        </p:nvPicPr>
+        <p:blipFill>
+          <a:blip r:embed="rId2"/>
+          <a:stretch>
+            <a:fillRect/>
+          </a:stretch>
+        </p:blipFill>
+        <p:spPr>
+          <a:xfrm>
+            <a:off x="731520" y="1783080"/>
+            <a:ext cx="4655344" cy="4206240"/>
+          </a:xfrm>
+          <a:prstGeom prst="rect">
+            <a:avLst/>
+          </a:prstGeom>
+        </p:spPr>
+      </p:pic>
+      <p:sp>
+        <p:nvSpPr>
+          <p:cNvPr id="6" name="TextBox 5"/>
+          <p:cNvSpPr txBox="1"/>
+          <p:nvPr/>
+        </p:nvSpPr>
+        <p:spPr>
+          <a:xfrm>
+            <a:off x="5852160" y="2011680"/>
+            <a:ext cx="5760720" cy="411480"/>
+          </a:xfrm>
+          <a:prstGeom prst="rect">
+            <a:avLst/>
+          </a:prstGeom>
+          <a:noFill/>
+        </p:spPr>
+        <p:txBody>
+          <a:bodyPr wrap="square">
+            <a:spAutoFit/>
+          </a:bodyPr>
+          <a:lstStyle/>
+          <a:p>
+            <a:r>
+              <a:rPr sz="1500" b="1">
                 <a:solidFill>
                   <a:srgbClr val="0E141B"/>
                 </a:solidFill>
               </a:rPr>
-              <a:t>1.  Features are still built label-dependently - the pipeline could not currently</a:t>
-            </a:r>
-          </a:p>
-        </p:txBody>
-      </p:sp>
-      <p:sp>
-        <p:nvSpPr>
-          <p:cNvPr id="6" name="TextBox 5"/>
-          <p:cNvSpPr txBox="1"/>
-          <p:nvPr/>
-        </p:nvSpPr>
-        <p:spPr>
-          <a:xfrm>
-            <a:off x="640080" y="2450592"/>
-            <a:ext cx="10972800" cy="411480"/>
-          </a:xfrm>
-          <a:prstGeom prst="rect">
-            <a:avLst/>
-          </a:prstGeom>
-          <a:noFill/>
-        </p:spPr>
-        <p:txBody>
-          <a:bodyPr wrap="square">
-            <a:spAutoFit/>
-          </a:bodyPr>
-          <a:lstStyle/>
-          <a:p>
-            <a:r>
-              <a:rPr sz="1700" b="0">
-                <a:solidFill>
-                  <a:srgbClr val="55606B"/>
-                </a:solidFill>
-              </a:rPr>
-              <a:t>        generate features for an unlabelled hidden test set.</a:t>
+              <a:t>37% of true Class 2 pixels are predicted Class 1.</a:t>
             </a:r>
           </a:p>
         </p:txBody>
@@ -6002,192 +6093,192 @@
         </p:nvSpPr>
         <p:spPr>
           <a:xfrm>
-            <a:off x="640080" y="2889504"/>
-            <a:ext cx="10972800" cy="411480"/>
-          </a:xfrm>
-          <a:prstGeom prst="rect">
-            <a:avLst/>
-          </a:prstGeom>
-          <a:noFill/>
-        </p:spPr>
-        <p:txBody>
-          <a:bodyPr wrap="square">
-            <a:spAutoFit/>
-          </a:bodyPr>
-          <a:lstStyle/>
-          <a:p>
-            <a:r>
-              <a:rPr sz="1700" b="1">
+            <a:off x="5852160" y="2816352"/>
+            <a:ext cx="5760720" cy="411480"/>
+          </a:xfrm>
+          <a:prstGeom prst="rect">
+            <a:avLst/>
+          </a:prstGeom>
+          <a:noFill/>
+        </p:spPr>
+        <p:txBody>
+          <a:bodyPr wrap="square">
+            <a:spAutoFit/>
+          </a:bodyPr>
+          <a:lstStyle/>
+          <a:p>
+            <a:r>
+              <a:rPr sz="1500" b="0">
+                <a:solidFill>
+                  <a:srgbClr val="55606B"/>
+                </a:solidFill>
+              </a:rPr>
+              <a:t>Zero-shot Class 3 was the sharpest failure:</a:t>
+            </a:r>
+          </a:p>
+        </p:txBody>
+      </p:sp>
+      <p:sp>
+        <p:nvSpPr>
+          <p:cNvPr id="8" name="TextBox 7"/>
+          <p:cNvSpPr txBox="1"/>
+          <p:nvPr/>
+        </p:nvSpPr>
+        <p:spPr>
+          <a:xfrm>
+            <a:off x="5852160" y="3218688"/>
+            <a:ext cx="5760720" cy="411480"/>
+          </a:xfrm>
+          <a:prstGeom prst="rect">
+            <a:avLst/>
+          </a:prstGeom>
+          <a:noFill/>
+        </p:spPr>
+        <p:txBody>
+          <a:bodyPr wrap="square">
+            <a:spAutoFit/>
+          </a:bodyPr>
+          <a:lstStyle/>
+          <a:p>
+            <a:r>
+              <a:rPr sz="1500" b="0">
+                <a:solidFill>
+                  <a:srgbClr val="55606B"/>
+                </a:solidFill>
+              </a:rPr>
+              <a:t>recall 0.19 against precision 0.77. The Madrid</a:t>
+            </a:r>
+          </a:p>
+        </p:txBody>
+      </p:sp>
+      <p:sp>
+        <p:nvSpPr>
+          <p:cNvPr id="9" name="TextBox 8"/>
+          <p:cNvSpPr txBox="1"/>
+          <p:nvPr/>
+        </p:nvSpPr>
+        <p:spPr>
+          <a:xfrm>
+            <a:off x="5852160" y="3621024"/>
+            <a:ext cx="5760720" cy="411480"/>
+          </a:xfrm>
+          <a:prstGeom prst="rect">
+            <a:avLst/>
+          </a:prstGeom>
+          <a:noFill/>
+        </p:spPr>
+        <p:txBody>
+          <a:bodyPr wrap="square">
+            <a:spAutoFit/>
+          </a:bodyPr>
+          <a:lstStyle/>
+          <a:p>
+            <a:r>
+              <a:rPr sz="1500" b="0">
+                <a:solidFill>
+                  <a:srgbClr val="55606B"/>
+                </a:solidFill>
+              </a:rPr>
+              <a:t>model almost never predicted it, but was usually</a:t>
+            </a:r>
+          </a:p>
+        </p:txBody>
+      </p:sp>
+      <p:sp>
+        <p:nvSpPr>
+          <p:cNvPr id="10" name="TextBox 9"/>
+          <p:cNvSpPr txBox="1"/>
+          <p:nvPr/>
+        </p:nvSpPr>
+        <p:spPr>
+          <a:xfrm>
+            <a:off x="5852160" y="4023360"/>
+            <a:ext cx="5760720" cy="411480"/>
+          </a:xfrm>
+          <a:prstGeom prst="rect">
+            <a:avLst/>
+          </a:prstGeom>
+          <a:noFill/>
+        </p:spPr>
+        <p:txBody>
+          <a:bodyPr wrap="square">
+            <a:spAutoFit/>
+          </a:bodyPr>
+          <a:lstStyle/>
+          <a:p>
+            <a:r>
+              <a:rPr sz="1500" b="0">
+                <a:solidFill>
+                  <a:srgbClr val="55606B"/>
+                </a:solidFill>
+              </a:rPr>
+              <a:t>right when it did.</a:t>
+            </a:r>
+          </a:p>
+        </p:txBody>
+      </p:sp>
+      <p:sp>
+        <p:nvSpPr>
+          <p:cNvPr id="11" name="TextBox 10"/>
+          <p:cNvSpPr txBox="1"/>
+          <p:nvPr/>
+        </p:nvSpPr>
+        <p:spPr>
+          <a:xfrm>
+            <a:off x="5852160" y="4828032"/>
+            <a:ext cx="5760720" cy="411480"/>
+          </a:xfrm>
+          <a:prstGeom prst="rect">
+            <a:avLst/>
+          </a:prstGeom>
+          <a:noFill/>
+        </p:spPr>
+        <p:txBody>
+          <a:bodyPr wrap="square">
+            <a:spAutoFit/>
+          </a:bodyPr>
+          <a:lstStyle/>
+          <a:p>
+            <a:r>
+              <a:rPr sz="1500" b="1">
                 <a:solidFill>
                   <a:srgbClr val="0E141B"/>
                 </a:solidFill>
               </a:rPr>
-              <a:t>2.  Scaling is fitted before cross-validation - not fold-safe.</a:t>
-            </a:r>
-          </a:p>
-        </p:txBody>
-      </p:sp>
-      <p:sp>
-        <p:nvSpPr>
-          <p:cNvPr id="8" name="TextBox 7"/>
-          <p:cNvSpPr txBox="1"/>
-          <p:nvPr/>
-        </p:nvSpPr>
-        <p:spPr>
-          <a:xfrm>
-            <a:off x="640080" y="3328416"/>
-            <a:ext cx="10972800" cy="411480"/>
-          </a:xfrm>
-          <a:prstGeom prst="rect">
-            <a:avLst/>
-          </a:prstGeom>
-          <a:noFill/>
-        </p:spPr>
-        <p:txBody>
-          <a:bodyPr wrap="square">
-            <a:spAutoFit/>
-          </a:bodyPr>
-          <a:lstStyle/>
-          <a:p>
-            <a:r>
-              <a:rPr sz="1700" b="1">
+              <a:t>Adjacent eras look alike from space. That is a</a:t>
+            </a:r>
+          </a:p>
+        </p:txBody>
+      </p:sp>
+      <p:sp>
+        <p:nvSpPr>
+          <p:cNvPr id="12" name="TextBox 11"/>
+          <p:cNvSpPr txBox="1"/>
+          <p:nvPr/>
+        </p:nvSpPr>
+        <p:spPr>
+          <a:xfrm>
+            <a:off x="5852160" y="5230368"/>
+            <a:ext cx="5760720" cy="411480"/>
+          </a:xfrm>
+          <a:prstGeom prst="rect">
+            <a:avLst/>
+          </a:prstGeom>
+          <a:noFill/>
+        </p:spPr>
+        <p:txBody>
+          <a:bodyPr wrap="square">
+            <a:spAutoFit/>
+          </a:bodyPr>
+          <a:lstStyle/>
+          <a:p>
+            <a:r>
+              <a:rPr sz="1500" b="1">
                 <a:solidFill>
                   <a:srgbClr val="0E141B"/>
                 </a:solidFill>
               </a:rPr>
-              <a:t>3.  Two methods were audited on the original set - so we crown no winner there.</a:t>
-            </a:r>
-          </a:p>
-        </p:txBody>
-      </p:sp>
-      <p:sp>
-        <p:nvSpPr>
-          <p:cNvPr id="9" name="TextBox 8"/>
-          <p:cNvSpPr txBox="1"/>
-          <p:nvPr/>
-        </p:nvSpPr>
-        <p:spPr>
-          <a:xfrm>
-            <a:off x="640080" y="3767328"/>
-            <a:ext cx="10972800" cy="411480"/>
-          </a:xfrm>
-          <a:prstGeom prst="rect">
-            <a:avLst/>
-          </a:prstGeom>
-          <a:noFill/>
-        </p:spPr>
-        <p:txBody>
-          <a:bodyPr wrap="square">
-            <a:spAutoFit/>
-          </a:bodyPr>
-          <a:lstStyle/>
-          <a:p>
-            <a:r>
-              <a:rPr sz="1700" b="0">
-                <a:solidFill>
-                  <a:srgbClr val="55606B"/>
-                </a:solidFill>
-              </a:rPr>
-              <a:t>        The headline result has since been replicated on an independent episode set.</a:t>
-            </a:r>
-          </a:p>
-        </p:txBody>
-      </p:sp>
-      <p:sp>
-        <p:nvSpPr>
-          <p:cNvPr id="10" name="TextBox 9"/>
-          <p:cNvSpPr txBox="1"/>
-          <p:nvPr/>
-        </p:nvSpPr>
-        <p:spPr>
-          <a:xfrm>
-            <a:off x="640080" y="4206240"/>
-            <a:ext cx="10972800" cy="411480"/>
-          </a:xfrm>
-          <a:prstGeom prst="rect">
-            <a:avLst/>
-          </a:prstGeom>
-          <a:noFill/>
-        </p:spPr>
-        <p:txBody>
-          <a:bodyPr wrap="square">
-            <a:spAutoFit/>
-          </a:bodyPr>
-          <a:lstStyle/>
-          <a:p>
-            <a:r>
-              <a:rPr sz="1700" b="1">
-                <a:solidFill>
-                  <a:srgbClr val="0E141B"/>
-                </a:solidFill>
-              </a:rPr>
-              <a:t>4.  No independent verification yet - Gate S needs a second person.</a:t>
-            </a:r>
-          </a:p>
-        </p:txBody>
-      </p:sp>
-      <p:sp>
-        <p:nvSpPr>
-          <p:cNvPr id="11" name="TextBox 10"/>
-          <p:cNvSpPr txBox="1"/>
-          <p:nvPr/>
-        </p:nvSpPr>
-        <p:spPr>
-          <a:xfrm>
-            <a:off x="640080" y="4645152"/>
-            <a:ext cx="10972800" cy="411480"/>
-          </a:xfrm>
-          <a:prstGeom prst="rect">
-            <a:avLst/>
-          </a:prstGeom>
-          <a:noFill/>
-        </p:spPr>
-        <p:txBody>
-          <a:bodyPr wrap="square">
-            <a:spAutoFit/>
-          </a:bodyPr>
-          <a:lstStyle/>
-          <a:p>
-            <a:r>
-              <a:rPr sz="1700" b="1">
-                <a:solidFill>
-                  <a:srgbClr val="0E141B"/>
-                </a:solidFill>
-              </a:rPr>
-              <a:t>5.  We appear to be near a label-noise ceiling.</a:t>
-            </a:r>
-          </a:p>
-        </p:txBody>
-      </p:sp>
-      <p:sp>
-        <p:nvSpPr>
-          <p:cNvPr id="12" name="TextBox 11"/>
-          <p:cNvSpPr txBox="1"/>
-          <p:nvPr/>
-        </p:nvSpPr>
-        <p:spPr>
-          <a:xfrm>
-            <a:off x="640080" y="5522976"/>
-            <a:ext cx="10972800" cy="411480"/>
-          </a:xfrm>
-          <a:prstGeom prst="rect">
-            <a:avLst/>
-          </a:prstGeom>
-          <a:noFill/>
-        </p:spPr>
-        <p:txBody>
-          <a:bodyPr wrap="square">
-            <a:spAutoFit/>
-          </a:bodyPr>
-          <a:lstStyle/>
-          <a:p>
-            <a:r>
-              <a:rPr sz="1700" b="0">
-                <a:solidFill>
-                  <a:srgbClr val="55606B"/>
-                </a:solidFill>
-              </a:rPr>
-              <a:t>No claims of worldwide portability. No claims of calibrated confidence.</a:t>
+              <a:t>property of the problem, not a bug to tune away.</a:t>
             </a:r>
           </a:p>
         </p:txBody>
@@ -6238,7 +6329,7 @@
                   <a:srgbClr val="0E141B"/>
                 </a:solidFill>
               </a:rPr>
-              <a:t>Conclusion</a:t>
+              <a:t>Limitations</a:t>
             </a:r>
           </a:p>
         </p:txBody>
@@ -6246,6 +6337,39 @@
       <p:sp>
         <p:nvSpPr>
           <p:cNvPr id="3" name="TextBox 2"/>
+          <p:cNvSpPr txBox="1"/>
+          <p:nvPr/>
+        </p:nvSpPr>
+        <p:spPr>
+          <a:xfrm>
+            <a:off x="548640" y="1234440"/>
+            <a:ext cx="11064240" cy="457200"/>
+          </a:xfrm>
+          <a:prstGeom prst="rect">
+            <a:avLst/>
+          </a:prstGeom>
+          <a:noFill/>
+        </p:spPr>
+        <p:txBody>
+          <a:bodyPr wrap="square">
+            <a:spAutoFit/>
+          </a:bodyPr>
+          <a:lstStyle/>
+          <a:p>
+            <a:r>
+              <a:rPr sz="1500">
+                <a:solidFill>
+                  <a:srgbClr val="55606B"/>
+                </a:solidFill>
+              </a:rPr>
+              <a:t>Stated, not hidden</a:t>
+            </a:r>
+          </a:p>
+        </p:txBody>
+      </p:sp>
+      <p:sp>
+        <p:nvSpPr>
+          <p:cNvPr id="4" name="TextBox 3"/>
           <p:cNvSpPr txBox="1"/>
           <p:nvPr/>
         </p:nvSpPr>
@@ -6272,20 +6396,20 @@
                   <a:srgbClr val="55606B"/>
                 </a:solidFill>
               </a:rPr>
-              <a:t>M1</a:t>
-            </a:r>
-          </a:p>
-        </p:txBody>
-      </p:sp>
-      <p:sp>
-        <p:nvSpPr>
-          <p:cNvPr id="4" name="TextBox 3"/>
-          <p:cNvSpPr txBox="1"/>
-          <p:nvPr/>
-        </p:nvSpPr>
-        <p:spPr>
-          <a:xfrm>
-            <a:off x="640080" y="2286000"/>
+              <a:t>M4</a:t>
+            </a:r>
+          </a:p>
+        </p:txBody>
+      </p:sp>
+      <p:sp>
+        <p:nvSpPr>
+          <p:cNvPr id="5" name="TextBox 4"/>
+          <p:cNvSpPr txBox="1"/>
+          <p:nvPr/>
+        </p:nvSpPr>
+        <p:spPr>
+          <a:xfrm>
+            <a:off x="640080" y="2011680"/>
             <a:ext cx="10972800" cy="411480"/>
           </a:xfrm>
           <a:prstGeom prst="rect">
@@ -6305,20 +6429,20 @@
                   <a:srgbClr val="0E141B"/>
                 </a:solidFill>
               </a:rPr>
-              <a:t>The starter's transfer learning transferred nothing. We proved it.</a:t>
-            </a:r>
-          </a:p>
-        </p:txBody>
-      </p:sp>
-      <p:sp>
-        <p:nvSpPr>
-          <p:cNvPr id="5" name="TextBox 4"/>
-          <p:cNvSpPr txBox="1"/>
-          <p:nvPr/>
-        </p:nvSpPr>
-        <p:spPr>
-          <a:xfrm>
-            <a:off x="640080" y="2944368"/>
+              <a:t>1.  Features are still built label-dependently - the pipeline could not currently</a:t>
+            </a:r>
+          </a:p>
+        </p:txBody>
+      </p:sp>
+      <p:sp>
+        <p:nvSpPr>
+          <p:cNvPr id="6" name="TextBox 5"/>
+          <p:cNvSpPr txBox="1"/>
+          <p:nvPr/>
+        </p:nvSpPr>
+        <p:spPr>
+          <a:xfrm>
+            <a:off x="640080" y="2450592"/>
             <a:ext cx="10972800" cy="411480"/>
           </a:xfrm>
           <a:prstGeom prst="rect">
@@ -6333,25 +6457,58 @@
           <a:lstStyle/>
           <a:p>
             <a:r>
+              <a:rPr sz="1700" b="0">
+                <a:solidFill>
+                  <a:srgbClr val="55606B"/>
+                </a:solidFill>
+              </a:rPr>
+              <a:t>        generate features for an unlabelled hidden test set.</a:t>
+            </a:r>
+          </a:p>
+        </p:txBody>
+      </p:sp>
+      <p:sp>
+        <p:nvSpPr>
+          <p:cNvPr id="7" name="TextBox 6"/>
+          <p:cNvSpPr txBox="1"/>
+          <p:nvPr/>
+        </p:nvSpPr>
+        <p:spPr>
+          <a:xfrm>
+            <a:off x="640080" y="2889504"/>
+            <a:ext cx="10972800" cy="411480"/>
+          </a:xfrm>
+          <a:prstGeom prst="rect">
+            <a:avLst/>
+          </a:prstGeom>
+          <a:noFill/>
+        </p:spPr>
+        <p:txBody>
+          <a:bodyPr wrap="square">
+            <a:spAutoFit/>
+          </a:bodyPr>
+          <a:lstStyle/>
+          <a:p>
+            <a:r>
               <a:rPr sz="1700" b="1">
                 <a:solidFill>
                   <a:srgbClr val="0E141B"/>
                 </a:solidFill>
               </a:rPr>
-              <a:t>We built one that does, and measured it against the right control.</a:t>
-            </a:r>
-          </a:p>
-        </p:txBody>
-      </p:sp>
-      <p:sp>
-        <p:nvSpPr>
-          <p:cNvPr id="6" name="TextBox 5"/>
-          <p:cNvSpPr txBox="1"/>
-          <p:nvPr/>
-        </p:nvSpPr>
-        <p:spPr>
-          <a:xfrm>
-            <a:off x="640080" y="3602736"/>
+              <a:t>2.  Scaling is fitted before cross-validation - not fold-safe.</a:t>
+            </a:r>
+          </a:p>
+        </p:txBody>
+      </p:sp>
+      <p:sp>
+        <p:nvSpPr>
+          <p:cNvPr id="8" name="TextBox 7"/>
+          <p:cNvSpPr txBox="1"/>
+          <p:nvPr/>
+        </p:nvSpPr>
+        <p:spPr>
+          <a:xfrm>
+            <a:off x="640080" y="3328416"/>
             <a:ext cx="10972800" cy="411480"/>
           </a:xfrm>
           <a:prstGeom prst="rect">
@@ -6371,40 +6528,139 @@
                   <a:srgbClr val="0E141B"/>
                 </a:solidFill>
               </a:rPr>
-              <a:t>The improvement is small. The method is sound. The failures are documented.</a:t>
-            </a:r>
-          </a:p>
-        </p:txBody>
-      </p:sp>
-      <p:sp>
-        <p:nvSpPr>
-          <p:cNvPr id="7" name="TextBox 6"/>
-          <p:cNvSpPr txBox="1"/>
-          <p:nvPr/>
-        </p:nvSpPr>
-        <p:spPr>
-          <a:xfrm>
-            <a:off x="822960" y="4572000"/>
-            <a:ext cx="10515600" cy="1097280"/>
-          </a:xfrm>
-          <a:prstGeom prst="rect">
-            <a:avLst/>
-          </a:prstGeom>
-          <a:noFill/>
-        </p:spPr>
-        <p:txBody>
-          <a:bodyPr wrap="square">
-            <a:spAutoFit/>
-          </a:bodyPr>
-          <a:lstStyle/>
-          <a:p>
-            <a:r>
-              <a:rPr sz="2600" b="1">
-                <a:solidFill>
-                  <a:srgbClr val="2A78D6"/>
-                </a:solidFill>
-              </a:rPr>
-              <a:t>A number without a mechanism is not a finding.</a:t>
+              <a:t>3.  Two methods were audited on the original set - so we crown no winner there.</a:t>
+            </a:r>
+          </a:p>
+        </p:txBody>
+      </p:sp>
+      <p:sp>
+        <p:nvSpPr>
+          <p:cNvPr id="9" name="TextBox 8"/>
+          <p:cNvSpPr txBox="1"/>
+          <p:nvPr/>
+        </p:nvSpPr>
+        <p:spPr>
+          <a:xfrm>
+            <a:off x="640080" y="3767328"/>
+            <a:ext cx="10972800" cy="411480"/>
+          </a:xfrm>
+          <a:prstGeom prst="rect">
+            <a:avLst/>
+          </a:prstGeom>
+          <a:noFill/>
+        </p:spPr>
+        <p:txBody>
+          <a:bodyPr wrap="square">
+            <a:spAutoFit/>
+          </a:bodyPr>
+          <a:lstStyle/>
+          <a:p>
+            <a:r>
+              <a:rPr sz="1700" b="0">
+                <a:solidFill>
+                  <a:srgbClr val="55606B"/>
+                </a:solidFill>
+              </a:rPr>
+              <a:t>        The headline result has since been replicated on an independent episode set.</a:t>
+            </a:r>
+          </a:p>
+        </p:txBody>
+      </p:sp>
+      <p:sp>
+        <p:nvSpPr>
+          <p:cNvPr id="10" name="TextBox 9"/>
+          <p:cNvSpPr txBox="1"/>
+          <p:nvPr/>
+        </p:nvSpPr>
+        <p:spPr>
+          <a:xfrm>
+            <a:off x="640080" y="4206240"/>
+            <a:ext cx="10972800" cy="411480"/>
+          </a:xfrm>
+          <a:prstGeom prst="rect">
+            <a:avLst/>
+          </a:prstGeom>
+          <a:noFill/>
+        </p:spPr>
+        <p:txBody>
+          <a:bodyPr wrap="square">
+            <a:spAutoFit/>
+          </a:bodyPr>
+          <a:lstStyle/>
+          <a:p>
+            <a:r>
+              <a:rPr sz="1700" b="1">
+                <a:solidFill>
+                  <a:srgbClr val="0E141B"/>
+                </a:solidFill>
+              </a:rPr>
+              <a:t>4.  No independent verification yet - Gate S needs a second person.</a:t>
+            </a:r>
+          </a:p>
+        </p:txBody>
+      </p:sp>
+      <p:sp>
+        <p:nvSpPr>
+          <p:cNvPr id="11" name="TextBox 10"/>
+          <p:cNvSpPr txBox="1"/>
+          <p:nvPr/>
+        </p:nvSpPr>
+        <p:spPr>
+          <a:xfrm>
+            <a:off x="640080" y="4645152"/>
+            <a:ext cx="10972800" cy="411480"/>
+          </a:xfrm>
+          <a:prstGeom prst="rect">
+            <a:avLst/>
+          </a:prstGeom>
+          <a:noFill/>
+        </p:spPr>
+        <p:txBody>
+          <a:bodyPr wrap="square">
+            <a:spAutoFit/>
+          </a:bodyPr>
+          <a:lstStyle/>
+          <a:p>
+            <a:r>
+              <a:rPr sz="1700" b="1">
+                <a:solidFill>
+                  <a:srgbClr val="0E141B"/>
+                </a:solidFill>
+              </a:rPr>
+              <a:t>5.  We appear to be near a label-noise ceiling.</a:t>
+            </a:r>
+          </a:p>
+        </p:txBody>
+      </p:sp>
+      <p:sp>
+        <p:nvSpPr>
+          <p:cNvPr id="12" name="TextBox 11"/>
+          <p:cNvSpPr txBox="1"/>
+          <p:nvPr/>
+        </p:nvSpPr>
+        <p:spPr>
+          <a:xfrm>
+            <a:off x="640080" y="5522976"/>
+            <a:ext cx="10972800" cy="411480"/>
+          </a:xfrm>
+          <a:prstGeom prst="rect">
+            <a:avLst/>
+          </a:prstGeom>
+          <a:noFill/>
+        </p:spPr>
+        <p:txBody>
+          <a:bodyPr wrap="square">
+            <a:spAutoFit/>
+          </a:bodyPr>
+          <a:lstStyle/>
+          <a:p>
+            <a:r>
+              <a:rPr sz="1700" b="0">
+                <a:solidFill>
+                  <a:srgbClr val="55606B"/>
+                </a:solidFill>
+              </a:rPr>
+              <a:t>No claims of worldwide portability. No claims of calibrated confidence.</a:t>
             </a:r>
           </a:p>
         </p:txBody>
@@ -6455,7 +6711,7 @@
                   <a:srgbClr val="0E141B"/>
                 </a:solidFill>
               </a:rPr>
-              <a:t>Backup - reproducibility</a:t>
+              <a:t>Conclusion</a:t>
             </a:r>
           </a:p>
         </p:txBody>
@@ -6468,27 +6724,28 @@
         </p:nvSpPr>
         <p:spPr>
           <a:xfrm>
-            <a:off x="548640" y="1234440"/>
-            <a:ext cx="11064240" cy="457200"/>
-          </a:xfrm>
-          <a:prstGeom prst="rect">
-            <a:avLst/>
-          </a:prstGeom>
-          <a:noFill/>
-        </p:spPr>
-        <p:txBody>
-          <a:bodyPr wrap="square">
-            <a:spAutoFit/>
-          </a:bodyPr>
-          <a:lstStyle/>
-          <a:p>
-            <a:r>
-              <a:rPr sz="1500">
-                <a:solidFill>
-                  <a:srgbClr val="55606B"/>
-                </a:solidFill>
-              </a:rPr>
-              <a:t>Everything is re-runnable</a:t>
+            <a:off x="10149840" y="6309360"/>
+            <a:ext cx="1645920" cy="365760"/>
+          </a:xfrm>
+          <a:prstGeom prst="rect">
+            <a:avLst/>
+          </a:prstGeom>
+          <a:noFill/>
+        </p:spPr>
+        <p:txBody>
+          <a:bodyPr wrap="square">
+            <a:spAutoFit/>
+          </a:bodyPr>
+          <a:lstStyle/>
+          <a:p>
+            <a:pPr algn="r"/>
+            <a:r>
+              <a:rPr sz="1000">
+                <a:solidFill>
+                  <a:srgbClr val="55606B"/>
+                </a:solidFill>
+              </a:rPr>
+              <a:t>M1</a:t>
             </a:r>
           </a:p>
         </p:txBody>
@@ -6501,7 +6758,7 @@
         </p:nvSpPr>
         <p:spPr>
           <a:xfrm>
-            <a:off x="640080" y="2011680"/>
+            <a:off x="640080" y="2286000"/>
             <a:ext cx="10972800" cy="411480"/>
           </a:xfrm>
           <a:prstGeom prst="rect">
@@ -6516,12 +6773,12 @@
           <a:lstStyle/>
           <a:p>
             <a:r>
-              <a:rPr sz="1700" b="0">
-                <a:solidFill>
-                  <a:srgbClr val="55606B"/>
-                </a:solidFill>
-              </a:rPr>
-              <a:t>requirements.txt pins the exact stack that produced every number.</a:t>
+              <a:rPr sz="1700" b="1">
+                <a:solidFill>
+                  <a:srgbClr val="0E141B"/>
+                </a:solidFill>
+              </a:rPr>
+              <a:t>The starter's transfer learning transferred nothing. We proved it.</a:t>
             </a:r>
           </a:p>
         </p:txBody>
@@ -6534,7 +6791,7 @@
         </p:nvSpPr>
         <p:spPr>
           <a:xfrm>
-            <a:off x="640080" y="2468880"/>
+            <a:off x="640080" y="2944368"/>
             <a:ext cx="10972800" cy="411480"/>
           </a:xfrm>
           <a:prstGeom prst="rect">
@@ -6549,12 +6806,12 @@
           <a:lstStyle/>
           <a:p>
             <a:r>
-              <a:rPr sz="1700" b="0">
-                <a:solidFill>
-                  <a:srgbClr val="55606B"/>
-                </a:solidFill>
-              </a:rPr>
-              <a:t>Raw data SHA256 recorded. Feature cache SHA256 f6f588c4...5f33.</a:t>
+              <a:rPr sz="1700" b="1">
+                <a:solidFill>
+                  <a:srgbClr val="0E141B"/>
+                </a:solidFill>
+              </a:rPr>
+              <a:t>We built one that does, and measured it against the right control.</a:t>
             </a:r>
           </a:p>
         </p:txBody>
@@ -6567,7 +6824,7 @@
         </p:nvSpPr>
         <p:spPr>
           <a:xfrm>
-            <a:off x="640080" y="2926080"/>
+            <a:off x="640080" y="3602736"/>
             <a:ext cx="10972800" cy="411480"/>
           </a:xfrm>
           <a:prstGeom prst="rect">
@@ -6582,12 +6839,12 @@
           <a:lstStyle/>
           <a:p>
             <a:r>
-              <a:rPr sz="1700" b="0">
-                <a:solidFill>
-                  <a:srgbClr val="55606B"/>
-                </a:solidFill>
-              </a:rPr>
-              <a:t>Episode support indices stored, not regenerated from a seed.</a:t>
+              <a:rPr sz="1700" b="1">
+                <a:solidFill>
+                  <a:srgbClr val="0E141B"/>
+                </a:solidFill>
+              </a:rPr>
+              <a:t>Five-shot macro F1 up 0.0515 over the target-only control, 40 of 50 episodes won.</a:t>
             </a:r>
           </a:p>
         </p:txBody>
@@ -6600,7 +6857,7 @@
         </p:nvSpPr>
         <p:spPr>
           <a:xfrm>
-            <a:off x="640080" y="3383280"/>
+            <a:off x="640080" y="4261104"/>
             <a:ext cx="10972800" cy="411480"/>
           </a:xfrm>
           <a:prstGeom prst="rect">
@@ -6615,12 +6872,12 @@
           <a:lstStyle/>
           <a:p>
             <a:r>
-              <a:rPr sz="1700" b="0">
-                <a:solidFill>
-                  <a:srgbClr val="55606B"/>
-                </a:solidFill>
-              </a:rPr>
-              <a:t>Stage 1 artifact is 3 KB. Reload test passes 17/17 in a clean session.</a:t>
+              <a:rPr sz="1700" b="1">
+                <a:solidFill>
+                  <a:srgbClr val="0E141B"/>
+                </a:solidFill>
+              </a:rPr>
+              <a:t>The failures are documented. The method is sound.</a:t>
             </a:r>
           </a:p>
         </p:txBody>
@@ -6633,60 +6890,27 @@
         </p:nvSpPr>
         <p:spPr>
           <a:xfrm>
-            <a:off x="640080" y="3840480"/>
-            <a:ext cx="10972800" cy="411480"/>
-          </a:xfrm>
-          <a:prstGeom prst="rect">
-            <a:avLst/>
-          </a:prstGeom>
-          <a:noFill/>
-        </p:spPr>
-        <p:txBody>
-          <a:bodyPr wrap="square">
-            <a:spAutoFit/>
-          </a:bodyPr>
-          <a:lstStyle/>
-          <a:p>
-            <a:r>
-              <a:rPr sz="1700" b="0">
-                <a:solidFill>
-                  <a:srgbClr val="55606B"/>
-                </a:solidFill>
-              </a:rPr>
-              <a:t>Seeds fixed throughout: RF 42, CV 42, sampler 42.</a:t>
-            </a:r>
-          </a:p>
-        </p:txBody>
-      </p:sp>
-      <p:sp>
-        <p:nvSpPr>
-          <p:cNvPr id="9" name="TextBox 8"/>
-          <p:cNvSpPr txBox="1"/>
-          <p:nvPr/>
-        </p:nvSpPr>
-        <p:spPr>
-          <a:xfrm>
-            <a:off x="640080" y="4297680"/>
-            <a:ext cx="10972800" cy="411480"/>
-          </a:xfrm>
-          <a:prstGeom prst="rect">
-            <a:avLst/>
-          </a:prstGeom>
-          <a:noFill/>
-        </p:spPr>
-        <p:txBody>
-          <a:bodyPr wrap="square">
-            <a:spAutoFit/>
-          </a:bodyPr>
-          <a:lstStyle/>
-          <a:p>
-            <a:r>
-              <a:rPr sz="1700" b="0">
-                <a:solidFill>
-                  <a:srgbClr val="55606B"/>
-                </a:solidFill>
-              </a:rPr>
-              <a:t>Ten commits, tagged day1-candidate-v1.</a:t>
+            <a:off x="822960" y="4572000"/>
+            <a:ext cx="10515600" cy="1097280"/>
+          </a:xfrm>
+          <a:prstGeom prst="rect">
+            <a:avLst/>
+          </a:prstGeom>
+          <a:noFill/>
+        </p:spPr>
+        <p:txBody>
+          <a:bodyPr wrap="square">
+            <a:spAutoFit/>
+          </a:bodyPr>
+          <a:lstStyle/>
+          <a:p>
+            <a:r>
+              <a:rPr sz="2600" b="1">
+                <a:solidFill>
+                  <a:srgbClr val="2A78D6"/>
+                </a:solidFill>
+              </a:rPr>
+              <a:t>A number without a mechanism is not a finding.</a:t>
             </a:r>
           </a:p>
         </p:txBody>
@@ -6737,7 +6961,7 @@
                   <a:srgbClr val="0E141B"/>
                 </a:solidFill>
               </a:rPr>
-              <a:t>Backup - why our numbers differ from the organiser's</a:t>
+              <a:t>Backup - reproducibility</a:t>
             </a:r>
           </a:p>
         </p:txBody>
@@ -6745,6 +6969,39 @@
       <p:sp>
         <p:nvSpPr>
           <p:cNvPr id="3" name="TextBox 2"/>
+          <p:cNvSpPr txBox="1"/>
+          <p:nvPr/>
+        </p:nvSpPr>
+        <p:spPr>
+          <a:xfrm>
+            <a:off x="548640" y="1234440"/>
+            <a:ext cx="11064240" cy="457200"/>
+          </a:xfrm>
+          <a:prstGeom prst="rect">
+            <a:avLst/>
+          </a:prstGeom>
+          <a:noFill/>
+        </p:spPr>
+        <p:txBody>
+          <a:bodyPr wrap="square">
+            <a:spAutoFit/>
+          </a:bodyPr>
+          <a:lstStyle/>
+          <a:p>
+            <a:r>
+              <a:rPr sz="1500">
+                <a:solidFill>
+                  <a:srgbClr val="55606B"/>
+                </a:solidFill>
+              </a:rPr>
+              <a:t>Everything is re-runnable</a:t>
+            </a:r>
+          </a:p>
+        </p:txBody>
+      </p:sp>
+      <p:sp>
+        <p:nvSpPr>
+          <p:cNvPr id="4" name="TextBox 3"/>
           <p:cNvSpPr txBox="1"/>
           <p:nvPr/>
         </p:nvSpPr>
@@ -6765,19 +7022,19 @@
           <a:lstStyle/>
           <a:p>
             <a:r>
-              <a:rPr sz="1700" b="1">
-                <a:solidFill>
-                  <a:srgbClr val="0E141B"/>
-                </a:solidFill>
-              </a:rPr>
-              <a:t>All six prototype budgets match them to 4 decimal places.</a:t>
-            </a:r>
-          </a:p>
-        </p:txBody>
-      </p:sp>
-      <p:sp>
-        <p:nvSpPr>
-          <p:cNvPr id="4" name="TextBox 3"/>
+              <a:rPr sz="1700" b="0">
+                <a:solidFill>
+                  <a:srgbClr val="55606B"/>
+                </a:solidFill>
+              </a:rPr>
+              <a:t>requirements.txt pins the exact stack that produced every number.</a:t>
+            </a:r>
+          </a:p>
+        </p:txBody>
+      </p:sp>
+      <p:sp>
+        <p:nvSpPr>
+          <p:cNvPr id="5" name="TextBox 4"/>
           <p:cNvSpPr txBox="1"/>
           <p:nvPr/>
         </p:nvSpPr>
@@ -6798,19 +7055,19 @@
           <a:lstStyle/>
           <a:p>
             <a:r>
-              <a:rPr sz="1700" b="1">
-                <a:solidFill>
-                  <a:srgbClr val="0E141B"/>
-                </a:solidFill>
-              </a:rPr>
-              <a:t>Both Random-Forest results differ: +0.0102 and +0.1006.</a:t>
-            </a:r>
-          </a:p>
-        </p:txBody>
-      </p:sp>
-      <p:sp>
-        <p:nvSpPr>
-          <p:cNvPr id="5" name="TextBox 4"/>
+              <a:rPr sz="1700" b="0">
+                <a:solidFill>
+                  <a:srgbClr val="55606B"/>
+                </a:solidFill>
+              </a:rPr>
+              <a:t>Raw data SHA256 recorded. Feature cache SHA256 f6f588c4...5f33.</a:t>
+            </a:r>
+          </a:p>
+        </p:txBody>
+      </p:sp>
+      <p:sp>
+        <p:nvSpPr>
+          <p:cNvPr id="6" name="TextBox 5"/>
           <p:cNvSpPr txBox="1"/>
           <p:nvPr/>
         </p:nvSpPr>
@@ -6836,14 +7093,14 @@
                   <a:srgbClr val="55606B"/>
                 </a:solidFill>
               </a:rPr>
-              <a:t>The prototype path never uses the forest, which isolates the cause to scikit-learn.</a:t>
-            </a:r>
-          </a:p>
-        </p:txBody>
-      </p:sp>
-      <p:sp>
-        <p:nvSpPr>
-          <p:cNvPr id="6" name="TextBox 5"/>
+              <a:t>Episode support indices stored, not regenerated from a seed.</a:t>
+            </a:r>
+          </a:p>
+        </p:txBody>
+      </p:sp>
+      <p:sp>
+        <p:nvSpPr>
+          <p:cNvPr id="7" name="TextBox 6"/>
           <p:cNvSpPr txBox="1"/>
           <p:nvPr/>
         </p:nvSpPr>
@@ -6869,14 +7126,14 @@
                   <a:srgbClr val="55606B"/>
                 </a:solidFill>
               </a:rPr>
-              <a:t>Determinism verified: 0 of 25,992 predictions differ across two refits.</a:t>
-            </a:r>
-          </a:p>
-        </p:txBody>
-      </p:sp>
-      <p:sp>
-        <p:nvSpPr>
-          <p:cNvPr id="7" name="TextBox 6"/>
+              <a:t>Stage 1 artifact is 3 KB. Reload test passes 17/17 in a clean session.</a:t>
+            </a:r>
+          </a:p>
+        </p:txBody>
+      </p:sp>
+      <p:sp>
+        <p:nvSpPr>
+          <p:cNvPr id="8" name="TextBox 7"/>
           <p:cNvSpPr txBox="1"/>
           <p:nvPr/>
         </p:nvSpPr>
@@ -6897,12 +7154,45 @@
           <a:lstStyle/>
           <a:p>
             <a:r>
-              <a:rPr sz="1700" b="1">
-                <a:solidFill>
-                  <a:srgbClr val="0E141B"/>
-                </a:solidFill>
-              </a:rPr>
-              <a:t>Still inferred, not measured - nobody installed the organiser's version to confirm.</a:t>
+              <a:rPr sz="1700" b="0">
+                <a:solidFill>
+                  <a:srgbClr val="55606B"/>
+                </a:solidFill>
+              </a:rPr>
+              <a:t>Seeds fixed throughout: RF 42, CV 42, sampler 42.</a:t>
+            </a:r>
+          </a:p>
+        </p:txBody>
+      </p:sp>
+      <p:sp>
+        <p:nvSpPr>
+          <p:cNvPr id="9" name="TextBox 8"/>
+          <p:cNvSpPr txBox="1"/>
+          <p:nvPr/>
+        </p:nvSpPr>
+        <p:spPr>
+          <a:xfrm>
+            <a:off x="640080" y="4297680"/>
+            <a:ext cx="10972800" cy="411480"/>
+          </a:xfrm>
+          <a:prstGeom prst="rect">
+            <a:avLst/>
+          </a:prstGeom>
+          <a:noFill/>
+        </p:spPr>
+        <p:txBody>
+          <a:bodyPr wrap="square">
+            <a:spAutoFit/>
+          </a:bodyPr>
+          <a:lstStyle/>
+          <a:p>
+            <a:r>
+              <a:rPr sz="1700" b="0">
+                <a:solidFill>
+                  <a:srgbClr val="55606B"/>
+                </a:solidFill>
+              </a:rPr>
+              <a:t>Ten commits, tagged day1-candidate-v1.</a:t>
             </a:r>
           </a:p>
         </p:txBody>
@@ -7463,6 +7753,222 @@
 </file>
 
 <file path=ppt/slides/slide20.xml><?xml version="1.0" encoding="utf-8"?>
+<p:sld xmlns:a="http://schemas.openxmlformats.org/drawingml/2006/main" xmlns:p="http://schemas.openxmlformats.org/presentationml/2006/main" xmlns:r="http://schemas.openxmlformats.org/officeDocument/2006/relationships">
+  <p:cSld>
+    <p:spTree>
+      <p:nvGrpSpPr>
+        <p:cNvPr id="1" name=""/>
+        <p:cNvGrpSpPr/>
+        <p:nvPr/>
+      </p:nvGrpSpPr>
+      <p:grpSpPr/>
+      <p:sp>
+        <p:nvSpPr>
+          <p:cNvPr id="2" name="TextBox 1"/>
+          <p:cNvSpPr txBox="1"/>
+          <p:nvPr/>
+        </p:nvSpPr>
+        <p:spPr>
+          <a:xfrm>
+            <a:off x="548640" y="365760"/>
+            <a:ext cx="11064240" cy="914400"/>
+          </a:xfrm>
+          <a:prstGeom prst="rect">
+            <a:avLst/>
+          </a:prstGeom>
+          <a:noFill/>
+        </p:spPr>
+        <p:txBody>
+          <a:bodyPr wrap="square">
+            <a:spAutoFit/>
+          </a:bodyPr>
+          <a:lstStyle/>
+          <a:p>
+            <a:r>
+              <a:rPr sz="3200" b="1">
+                <a:solidFill>
+                  <a:srgbClr val="0E141B"/>
+                </a:solidFill>
+              </a:rPr>
+              <a:t>Backup - why our numbers differ from the organiser's</a:t>
+            </a:r>
+          </a:p>
+        </p:txBody>
+      </p:sp>
+      <p:sp>
+        <p:nvSpPr>
+          <p:cNvPr id="3" name="TextBox 2"/>
+          <p:cNvSpPr txBox="1"/>
+          <p:nvPr/>
+        </p:nvSpPr>
+        <p:spPr>
+          <a:xfrm>
+            <a:off x="640080" y="2011680"/>
+            <a:ext cx="10972800" cy="411480"/>
+          </a:xfrm>
+          <a:prstGeom prst="rect">
+            <a:avLst/>
+          </a:prstGeom>
+          <a:noFill/>
+        </p:spPr>
+        <p:txBody>
+          <a:bodyPr wrap="square">
+            <a:spAutoFit/>
+          </a:bodyPr>
+          <a:lstStyle/>
+          <a:p>
+            <a:r>
+              <a:rPr sz="1700" b="1">
+                <a:solidFill>
+                  <a:srgbClr val="0E141B"/>
+                </a:solidFill>
+              </a:rPr>
+              <a:t>All six prototype budgets match them to 4 decimal places.</a:t>
+            </a:r>
+          </a:p>
+        </p:txBody>
+      </p:sp>
+      <p:sp>
+        <p:nvSpPr>
+          <p:cNvPr id="4" name="TextBox 3"/>
+          <p:cNvSpPr txBox="1"/>
+          <p:nvPr/>
+        </p:nvSpPr>
+        <p:spPr>
+          <a:xfrm>
+            <a:off x="640080" y="2468880"/>
+            <a:ext cx="10972800" cy="411480"/>
+          </a:xfrm>
+          <a:prstGeom prst="rect">
+            <a:avLst/>
+          </a:prstGeom>
+          <a:noFill/>
+        </p:spPr>
+        <p:txBody>
+          <a:bodyPr wrap="square">
+            <a:spAutoFit/>
+          </a:bodyPr>
+          <a:lstStyle/>
+          <a:p>
+            <a:r>
+              <a:rPr sz="1700" b="1">
+                <a:solidFill>
+                  <a:srgbClr val="0E141B"/>
+                </a:solidFill>
+              </a:rPr>
+              <a:t>Both Random-Forest results differ: +0.0102 and +0.1006.</a:t>
+            </a:r>
+          </a:p>
+        </p:txBody>
+      </p:sp>
+      <p:sp>
+        <p:nvSpPr>
+          <p:cNvPr id="5" name="TextBox 4"/>
+          <p:cNvSpPr txBox="1"/>
+          <p:nvPr/>
+        </p:nvSpPr>
+        <p:spPr>
+          <a:xfrm>
+            <a:off x="640080" y="2926080"/>
+            <a:ext cx="10972800" cy="411480"/>
+          </a:xfrm>
+          <a:prstGeom prst="rect">
+            <a:avLst/>
+          </a:prstGeom>
+          <a:noFill/>
+        </p:spPr>
+        <p:txBody>
+          <a:bodyPr wrap="square">
+            <a:spAutoFit/>
+          </a:bodyPr>
+          <a:lstStyle/>
+          <a:p>
+            <a:r>
+              <a:rPr sz="1700" b="0">
+                <a:solidFill>
+                  <a:srgbClr val="55606B"/>
+                </a:solidFill>
+              </a:rPr>
+              <a:t>The prototype path never uses the forest, which isolates the cause to scikit-learn.</a:t>
+            </a:r>
+          </a:p>
+        </p:txBody>
+      </p:sp>
+      <p:sp>
+        <p:nvSpPr>
+          <p:cNvPr id="6" name="TextBox 5"/>
+          <p:cNvSpPr txBox="1"/>
+          <p:nvPr/>
+        </p:nvSpPr>
+        <p:spPr>
+          <a:xfrm>
+            <a:off x="640080" y="3383280"/>
+            <a:ext cx="10972800" cy="411480"/>
+          </a:xfrm>
+          <a:prstGeom prst="rect">
+            <a:avLst/>
+          </a:prstGeom>
+          <a:noFill/>
+        </p:spPr>
+        <p:txBody>
+          <a:bodyPr wrap="square">
+            <a:spAutoFit/>
+          </a:bodyPr>
+          <a:lstStyle/>
+          <a:p>
+            <a:r>
+              <a:rPr sz="1700" b="0">
+                <a:solidFill>
+                  <a:srgbClr val="55606B"/>
+                </a:solidFill>
+              </a:rPr>
+              <a:t>Determinism verified: 0 of 25,992 predictions differ across two refits.</a:t>
+            </a:r>
+          </a:p>
+        </p:txBody>
+      </p:sp>
+      <p:sp>
+        <p:nvSpPr>
+          <p:cNvPr id="7" name="TextBox 6"/>
+          <p:cNvSpPr txBox="1"/>
+          <p:nvPr/>
+        </p:nvSpPr>
+        <p:spPr>
+          <a:xfrm>
+            <a:off x="640080" y="3840480"/>
+            <a:ext cx="10972800" cy="411480"/>
+          </a:xfrm>
+          <a:prstGeom prst="rect">
+            <a:avLst/>
+          </a:prstGeom>
+          <a:noFill/>
+        </p:spPr>
+        <p:txBody>
+          <a:bodyPr wrap="square">
+            <a:spAutoFit/>
+          </a:bodyPr>
+          <a:lstStyle/>
+          <a:p>
+            <a:r>
+              <a:rPr sz="1700" b="1">
+                <a:solidFill>
+                  <a:srgbClr val="0E141B"/>
+                </a:solidFill>
+              </a:rPr>
+              <a:t>Still inferred, not measured - nobody installed the organiser's version to confirm.</a:t>
+            </a:r>
+          </a:p>
+        </p:txBody>
+      </p:sp>
+    </p:spTree>
+  </p:cSld>
+  <p:clrMapOvr>
+    <a:masterClrMapping/>
+  </p:clrMapOvr>
+</p:sld>
+</file>
+
+<file path=ppt/slides/slide21.xml><?xml version="1.0" encoding="utf-8"?>
 <p:sld xmlns:a="http://schemas.openxmlformats.org/drawingml/2006/main" xmlns:p="http://schemas.openxmlformats.org/presentationml/2006/main" xmlns:r="http://schemas.openxmlformats.org/officeDocument/2006/relationships">
   <p:cSld>
     <p:spTree>

</xml_diff>